<commit_message>
Cut the LLM wiki segment of the week 5 deck from eight cards to three
The segment is a live demo, and eight cards told the story the demo is there to show: what to
watch for, the disagreement between two sources, the query trail, the costs of switching.
Each of those was a card a student would read while the lecturer was showing it on screen.

Three cards are left, each carrying only what the voice cannot: the shape of the wiki (three
folders, three owners, with Karpathy's idea file linked), the three sources as links, and the
template's address with the one rule that cannot be missed. Everything cut moved into
week-05-notes.md under the card it belongs to, so the demo's run sheet sits under card 4 in one
piece. The week page still carries the full text for students who read afterwards.

Co-Authored-By: Claude Opus 5.5 <noreply@anthropic.com>
</commit_message>
<xml_diff>
--- a/project-documentation/slides/week-05-deck.pptx
+++ b/project-documentation/slides/week-05-deck.pptx
@@ -11,11 +11,6 @@
     <p:sldId id="259" r:id="rId11"/>
     <p:sldId id="260" r:id="rId12"/>
     <p:sldId id="261" r:id="rId13"/>
-    <p:sldId id="262" r:id="rId14"/>
-    <p:sldId id="263" r:id="rId15"/>
-    <p:sldId id="264" r:id="rId16"/>
-    <p:sldId id="265" r:id="rId17"/>
-    <p:sldId id="266" r:id="rId18"/>
   </p:sldIdLst>
   <p:sldSz cx="12191695" cy="6858000" type="screen4x3"/>
   <p:notesSz cx="6858000" cy="9144000"/>
@@ -537,146 +532,6 @@
 </p:notes>
 </file>
 
-<file path=ppt/notesSlides/notesSlide10.xml><?xml version="1.0" encoding="utf-8"?>
-<p:notes xmlns:a="http://schemas.openxmlformats.org/drawingml/2006/main" xmlns:p="http://schemas.openxmlformats.org/presentationml/2006/main" xmlns:r="http://schemas.openxmlformats.org/officeDocument/2006/relationships">
-  <p:cSld>
-    <p:spTree>
-      <p:nvGrpSpPr>
-        <p:cNvPr id="1" name=""/>
-        <p:cNvGrpSpPr/>
-        <p:nvPr/>
-      </p:nvGrpSpPr>
-      <p:grpSpPr>
-        <a:xfrm>
-          <a:off x="0" y="0"/>
-          <a:ext cx="0" cy="0"/>
-          <a:chOff x="0" y="0"/>
-          <a:chExt cx="0" cy="0"/>
-        </a:xfrm>
-      </p:grpSpPr>
-      <p:sp>
-        <p:nvSpPr>
-          <p:cNvPr id="2" name="Slide Image Placeholder 1"/>
-          <p:cNvSpPr>
-            <a:spLocks noGrp="1"/>
-          </p:cNvSpPr>
-          <p:nvPr>
-            <p:ph type="sldImg" idx="2"/>
-          </p:nvPr>
-        </p:nvSpPr>
-        <p:spPr/>
-      </p:sp>
-      <p:sp>
-        <p:nvSpPr>
-          <p:cNvPr id="3" name="Notes Placeholder 2"/>
-          <p:cNvSpPr>
-            <a:spLocks noGrp="1"/>
-          </p:cNvSpPr>
-          <p:nvPr>
-            <p:ph type="body" idx="3" sz="quarter"/>
-          </p:nvPr>
-        </p:nvSpPr>
-        <p:spPr/>
-        <p:txBody>
-          <a:bodyPr/>
-          <a:lstStyle/>
-          <a:p>
-            <a:r>
-              <a:t>Nobody has to switch. A folder with a naming rule, traced end to end, is still a good answer. What the wiki costs: every source is read when it arrives whether anyone asks or not; a misreading lands on several pages at once; past a few hundred pages the index is not enough. A team that adopts it writes a decision-log entry and versions its knowledge architecture.</a:t>
-            </a:r>
-          </a:p>
-        </p:txBody>
-      </p:sp>
-      <p:sp>
-        <p:nvSpPr>
-          <p:cNvPr id="4" name="Slide Number Placeholder 3"/>
-          <p:cNvSpPr>
-            <a:spLocks noGrp="1"/>
-          </p:cNvSpPr>
-          <p:nvPr>
-            <p:ph type="sldNum" idx="5" sz="quarter"/>
-          </p:nvPr>
-        </p:nvSpPr>
-        <p:spPr/>
-      </p:sp>
-    </p:spTree>
-  </p:cSld>
-  <p:clrMapOvr>
-    <a:masterClrMapping/>
-  </p:clrMapOvr>
-</p:notes>
-</file>
-
-<file path=ppt/notesSlides/notesSlide11.xml><?xml version="1.0" encoding="utf-8"?>
-<p:notes xmlns:a="http://schemas.openxmlformats.org/drawingml/2006/main" xmlns:p="http://schemas.openxmlformats.org/presentationml/2006/main" xmlns:r="http://schemas.openxmlformats.org/officeDocument/2006/relationships">
-  <p:cSld>
-    <p:spTree>
-      <p:nvGrpSpPr>
-        <p:cNvPr id="1" name=""/>
-        <p:cNvGrpSpPr/>
-        <p:nvPr/>
-      </p:nvGrpSpPr>
-      <p:grpSpPr>
-        <a:xfrm>
-          <a:off x="0" y="0"/>
-          <a:ext cx="0" cy="0"/>
-          <a:chOff x="0" y="0"/>
-          <a:chExt cx="0" cy="0"/>
-        </a:xfrm>
-      </p:grpSpPr>
-      <p:sp>
-        <p:nvSpPr>
-          <p:cNvPr id="2" name="Slide Image Placeholder 1"/>
-          <p:cNvSpPr>
-            <a:spLocks noGrp="1"/>
-          </p:cNvSpPr>
-          <p:nvPr>
-            <p:ph type="sldImg" idx="2"/>
-          </p:nvPr>
-        </p:nvSpPr>
-        <p:spPr/>
-      </p:sp>
-      <p:sp>
-        <p:nvSpPr>
-          <p:cNvPr id="3" name="Notes Placeholder 2"/>
-          <p:cNvSpPr>
-            <a:spLocks noGrp="1"/>
-          </p:cNvSpPr>
-          <p:nvPr>
-            <p:ph type="body" idx="3" sz="quarter"/>
-          </p:nvPr>
-        </p:nvSpPr>
-        <p:spPr/>
-        <p:txBody>
-          <a:bodyPr/>
-          <a:lstStyle/>
-          <a:p>
-            <a:r>
-              <a:t>The first evaluation is held against the PRD's own criteria. The decision log travels with it. The lookup record and the quotation check are what let a team explain a wrong sentence on its page instead of guessing.</a:t>
-            </a:r>
-          </a:p>
-        </p:txBody>
-      </p:sp>
-      <p:sp>
-        <p:nvSpPr>
-          <p:cNvPr id="4" name="Slide Number Placeholder 3"/>
-          <p:cNvSpPr>
-            <a:spLocks noGrp="1"/>
-          </p:cNvSpPr>
-          <p:nvPr>
-            <p:ph type="sldNum" idx="5" sz="quarter"/>
-          </p:nvPr>
-        </p:nvSpPr>
-        <p:spPr/>
-      </p:sp>
-    </p:spTree>
-  </p:cSld>
-  <p:clrMapOvr>
-    <a:masterClrMapping/>
-  </p:clrMapOvr>
-</p:notes>
-</file>
-
 <file path=ppt/notesSlides/notesSlide2.xml><?xml version="1.0" encoding="utf-8"?>
 <p:notes xmlns:a="http://schemas.openxmlformats.org/drawingml/2006/main" xmlns:p="http://schemas.openxmlformats.org/presentationml/2006/main" xmlns:r="http://schemas.openxmlformats.org/officeDocument/2006/relationships">
   <p:cSld>
@@ -792,7 +647,13 @@
           <a:lstStyle/>
           <a:p>
             <a:r>
-              <a:t>Most of what the teams built in week 4 looks things up at the moment a question is asked: files uploaded to a chat, a folder the assistant searches, a vector store. That works, and it forgets. Ask the same question twice and it does the work twice; a contradiction between two sources is found only if a question happens to touch both. Karpathy's point is that nothing accumulates. The week 3 visualisation is the reminder that this is one of four options, not the new default.</a:t>
+              <a:t>Most of what the teams built in week 4 looks things up when a question is asked: files uploaded to a chat, a folder the assistant searches, a vector store. That works, and it forgets. Ask twice and it does the work twice; a contradiction between two sources is found only if a question happens to touch both. Karpathy: the LLM "is rediscovering knowledge from scratch on every question". The week 3 visualisation (one question, four ways) is the reminder that this is one of four options.</a:t>
+            </a:r>
+          </a:p>
+          <a:p/>
+          <a:p>
+            <a:r>
+              <a:t>Then the three folders, three owners. raw/ is the evidence and nobody edits it, the assistant included. wiki/ belongs to the assistant; the team reads and asks for changes. AGENTS.md is the contract, and the team changes it. All six assistants the students use read AGENTS.md; CLAUDE.md and GEMINI.md point to it.</a:t>
             </a:r>
           </a:p>
         </p:txBody>
@@ -862,7 +723,62 @@
           <a:lstStyle/>
           <a:p>
             <a:r>
-              <a:t>Three folders, three owners. raw/ is the evidence and is never edited, the assistant included. wiki/ belongs to the assistant: the team reads it and asks for changes. AGENTS.md is the contract, and the team changes it when it does not fit. All six assistants the students use read AGENTS.md; CLAUDE.md and GEMINI.md in the template point to it.</a:t>
+              <a:t>The demo. Leave this card up and switch to the terminal and Obsidian.</a:t>
+            </a:r>
+          </a:p>
+          <a:p/>
+          <a:p>
+            <a:r>
+              <a:t>Acquire, one command per format:</a:t>
+            </a:r>
+          </a:p>
+          <a:p/>
+          <a:p>
+            <a:r>
+              <a:t>• Article: `python3 tools/fetch_article.py https://oecdcogito.blog/2025/09/16/agentic-ai-for-small-business-growth/` — about 1,800 words, word for word.</a:t>
+            </a:r>
+          </a:p>
+          <a:p>
+            <a:r>
+              <a:t>• Video: `python3 tools/fetch_youtube.py https://www.youtube.com/watch?v=51lXx4wBuHE` — captions only; 64 minutes, about 7,600 words of automatic captions.</a:t>
+            </a:r>
+          </a:p>
+          <a:p>
+            <a:r>
+              <a:t>• Report: save the PDF in raw/reports/, then `markitdown raw/reports/oecd-empowering-smes-in-the-age-of-ai.pdf &gt; raw/reports/oecd-empowering-smes-in-the-age-of-ai.md` — 36 pages, about 13,000 words, four seconds. The PDF itself is not committed (.gitignore).</a:t>
+            </a:r>
+          </a:p>
+          <a:p/>
+          <a:p>
+            <a:r>
+              <a:t>Process: `/ingest raw/articles/agentic-ai-for-small-business-growth.md — added by Witek`. Let the pause happen; read the takeaways aloud before saying go. Dry run on 30 September, headless, no pause: the article took just under five minutes and wrote twelve pages. With the pause and talking, budget eight. If time is short, ingest the video and the report while talking.</a:t>
+            </a:r>
+          </a:p>
+          <a:p/>
+          <a:p>
+            <a:r>
+              <a:t>Four things to show:</a:t>
+            </a:r>
+          </a:p>
+          <a:p/>
+          <a:p>
+            <a:r>
+              <a:t>1. The pause: the place to catch a misreading before it lands on ten pages.</a:t>
+            </a:r>
+          </a:p>
+          <a:p>
+            <a:r>
+              <a:t>2. The source page's caveats. In the dry run it found that the author heads PayPal's government relations, that PayPal is a partner of the survey the article cites, that the "72%" figure links back to the article itself, and that the two business owners are invented examples.</a:t>
+            </a:r>
+          </a:p>
+          <a:p>
+            <a:r>
+              <a:t>3. The disagreement, once the report is in: the article's assistant "negotiates with suppliers"; the OECD finds 61% of SMEs use AI and 76% of those are "AI novices". Show the Debates section and the confidence number that went down. The OECD calls its own sample non-representative, and the source page should say so.</a:t>
+            </a:r>
+          </a:p>
+          <a:p>
+            <a:r>
+              <a:t>4. Query and lint. Ask: *Which AI uses pay off first for a small manufacturer, according to the wiki?* Show the citations, then the query entry in the log with the pages it read. Then `/lint`, and dwell on the quote check: every quotation on a wiki page is compared with the raw file, so an invented quotation fails. These are the two habits the knowledge architecture criteria said would come back in week 5.</a:t>
             </a:r>
           </a:p>
         </p:txBody>
@@ -932,29 +848,13 @@
           <a:lstStyle/>
           <a:p>
             <a:r>
-              <a:t>Demo, part 1 (acquire). One command per format, each lands a markdown file in raw/:</a:t>
+              <a:t>Teams make their copy now if they did not before the session; the README has the steps. Walk the room: the usual problems are Python on Windows (`python`, not `python3`) and a venv that is not activated. Each team ingests one published source of its own and reads the source page back. Never interview material, private repository or not: what the assistant reads goes to a model service.</a:t>
             </a:r>
           </a:p>
           <a:p/>
           <a:p>
             <a:r>
-              <a:t>• Article: `python3 tools/fetch_article.py https://oecdcogito.blog/2025/09/16/agentic-ai-for-small-business-growth/` — about 1,800 words, verbatim.</a:t>
-            </a:r>
-          </a:p>
-          <a:p>
-            <a:r>
-              <a:t>• Video: `python3 tools/fetch_youtube.py https://www.youtube.com/watch?v=51lXx4wBuHE` — captions only, the video is not downloaded; 64 minutes, about 7,600 words of automatic captions.</a:t>
-            </a:r>
-          </a:p>
-          <a:p>
-            <a:r>
-              <a:t>• Report: save the PDF in raw/reports/, then `markitdown raw/reports/oecd-empowering-smes-in-the-age-of-ai.pdf &gt; raw/reports/oecd-empowering-smes-in-the-age-of-ai.md` — 36 pages, about 13,000 words, four seconds.</a:t>
-            </a:r>
-          </a:p>
-          <a:p/>
-          <a:p>
-            <a:r>
-              <a:t>Point out that the PDF itself is not committed (.gitignore): the text is, and the source page says where the original lives.</a:t>
+              <a:t>Nobody has to switch. A folder with a naming rule, traced end to end, is still a good answer. What the wiki costs: every source is read when it arrives, whether anyone asks or not; a misreading lands on several pages at once; past a few hundred pages the index is not enough and you need search. A team that adopts it writes a decision-log entry and versions its knowledge architecture.</a:t>
             </a:r>
           </a:p>
         </p:txBody>
@@ -1024,223 +924,7 @@
           <a:lstStyle/>
           <a:p>
             <a:r>
-              <a:t>Demo, part 2 (process). In Claude Code: `/ingest raw/articles/agentic-ai-for-small-business-growth.md — added by Witek`. Let the pause happen and read the takeaways out loud before saying go. On the source page, show the byline: a PayPal author on the OECD's blog, and the two business owners in it are invented examples. Then open wiki/index.md and wiki/log.md.</a:t>
-            </a:r>
-          </a:p>
-          <a:p/>
-          <a:p>
-            <a:r>
-              <a:t>Dry run on 30 September, headless, no pause: the article took just under five minutes and wrote twelve pages. With the pause and talking, budget eight. Ingest the article live; if time is short, run the video and the report while talking over s7.</a:t>
-            </a:r>
-          </a:p>
-        </p:txBody>
-      </p:sp>
-      <p:sp>
-        <p:nvSpPr>
-          <p:cNvPr id="4" name="Slide Number Placeholder 3"/>
-          <p:cNvSpPr>
-            <a:spLocks noGrp="1"/>
-          </p:cNvSpPr>
-          <p:nvPr>
-            <p:ph type="sldNum" idx="5" sz="quarter"/>
-          </p:nvPr>
-        </p:nvSpPr>
-        <p:spPr/>
-      </p:sp>
-    </p:spTree>
-  </p:cSld>
-  <p:clrMapOvr>
-    <a:masterClrMapping/>
-  </p:clrMapOvr>
-</p:notes>
-</file>
-
-<file path=ppt/notesSlides/notesSlide7.xml><?xml version="1.0" encoding="utf-8"?>
-<p:notes xmlns:a="http://schemas.openxmlformats.org/drawingml/2006/main" xmlns:p="http://schemas.openxmlformats.org/presentationml/2006/main" xmlns:r="http://schemas.openxmlformats.org/officeDocument/2006/relationships">
-  <p:cSld>
-    <p:spTree>
-      <p:nvGrpSpPr>
-        <p:cNvPr id="1" name=""/>
-        <p:cNvGrpSpPr/>
-        <p:nvPr/>
-      </p:nvGrpSpPr>
-      <p:grpSpPr>
-        <a:xfrm>
-          <a:off x="0" y="0"/>
-          <a:ext cx="0" cy="0"/>
-          <a:chOff x="0" y="0"/>
-          <a:chExt cx="0" cy="0"/>
-        </a:xfrm>
-      </p:grpSpPr>
-      <p:sp>
-        <p:nvSpPr>
-          <p:cNvPr id="2" name="Slide Image Placeholder 1"/>
-          <p:cNvSpPr>
-            <a:spLocks noGrp="1"/>
-          </p:cNvSpPr>
-          <p:nvPr>
-            <p:ph type="sldImg" idx="2"/>
-          </p:nvPr>
-        </p:nvSpPr>
-        <p:spPr/>
-      </p:sp>
-      <p:sp>
-        <p:nvSpPr>
-          <p:cNvPr id="3" name="Notes Placeholder 2"/>
-          <p:cNvSpPr>
-            <a:spLocks noGrp="1"/>
-          </p:cNvSpPr>
-          <p:nvPr>
-            <p:ph type="body" idx="3" sz="quarter"/>
-          </p:nvPr>
-        </p:nvSpPr>
-        <p:spPr/>
-        <p:txBody>
-          <a:bodyPr/>
-          <a:lstStyle/>
-          <a:p>
-            <a:r>
-              <a:t>The disagreement the wiki should surface once both are in: the article describes an assistant that runs inventory and negotiates with suppliers; the OECD's own survey finds most SME users are novices using off-the-shelf tools. Show where it lands — the Debates section of the concept page, and the confidence number that went down. Also worth a sentence: the OECD calls its own sample non-representative, and the source page should say so.</a:t>
-            </a:r>
-          </a:p>
-        </p:txBody>
-      </p:sp>
-      <p:sp>
-        <p:nvSpPr>
-          <p:cNvPr id="4" name="Slide Number Placeholder 3"/>
-          <p:cNvSpPr>
-            <a:spLocks noGrp="1"/>
-          </p:cNvSpPr>
-          <p:nvPr>
-            <p:ph type="sldNum" idx="5" sz="quarter"/>
-          </p:nvPr>
-        </p:nvSpPr>
-        <p:spPr/>
-      </p:sp>
-    </p:spTree>
-  </p:cSld>
-  <p:clrMapOvr>
-    <a:masterClrMapping/>
-  </p:clrMapOvr>
-</p:notes>
-</file>
-
-<file path=ppt/notesSlides/notesSlide8.xml><?xml version="1.0" encoding="utf-8"?>
-<p:notes xmlns:a="http://schemas.openxmlformats.org/drawingml/2006/main" xmlns:p="http://schemas.openxmlformats.org/presentationml/2006/main" xmlns:r="http://schemas.openxmlformats.org/officeDocument/2006/relationships">
-  <p:cSld>
-    <p:spTree>
-      <p:nvGrpSpPr>
-        <p:cNvPr id="1" name=""/>
-        <p:cNvGrpSpPr/>
-        <p:nvPr/>
-      </p:nvGrpSpPr>
-      <p:grpSpPr>
-        <a:xfrm>
-          <a:off x="0" y="0"/>
-          <a:ext cx="0" cy="0"/>
-          <a:chOff x="0" y="0"/>
-          <a:chExt cx="0" cy="0"/>
-        </a:xfrm>
-      </p:grpSpPr>
-      <p:sp>
-        <p:nvSpPr>
-          <p:cNvPr id="2" name="Slide Image Placeholder 1"/>
-          <p:cNvSpPr>
-            <a:spLocks noGrp="1"/>
-          </p:cNvSpPr>
-          <p:nvPr>
-            <p:ph type="sldImg" idx="2"/>
-          </p:nvPr>
-        </p:nvSpPr>
-        <p:spPr/>
-      </p:sp>
-      <p:sp>
-        <p:nvSpPr>
-          <p:cNvPr id="3" name="Notes Placeholder 2"/>
-          <p:cNvSpPr>
-            <a:spLocks noGrp="1"/>
-          </p:cNvSpPr>
-          <p:nvPr>
-            <p:ph type="body" idx="3" sz="quarter"/>
-          </p:nvPr>
-        </p:nvSpPr>
-        <p:spPr/>
-        <p:txBody>
-          <a:bodyPr/>
-          <a:lstStyle/>
-          <a:p>
-            <a:r>
-              <a:t>Demo, part 3 (query and lint). Ask: *Which AI uses pay off first for a small manufacturer, according to the wiki?* Show the citations, then the query entry in the log with the pages it read. Then `/lint`. The quote check is the one to dwell on: it compares every quotation on a wiki page with the raw file, so an invented quotation fails. These are the two habits the knowledge architecture criteria said would come back in week 5.</a:t>
-            </a:r>
-          </a:p>
-        </p:txBody>
-      </p:sp>
-      <p:sp>
-        <p:nvSpPr>
-          <p:cNvPr id="4" name="Slide Number Placeholder 3"/>
-          <p:cNvSpPr>
-            <a:spLocks noGrp="1"/>
-          </p:cNvSpPr>
-          <p:nvPr>
-            <p:ph type="sldNum" idx="5" sz="quarter"/>
-          </p:nvPr>
-        </p:nvSpPr>
-        <p:spPr/>
-      </p:sp>
-    </p:spTree>
-  </p:cSld>
-  <p:clrMapOvr>
-    <a:masterClrMapping/>
-  </p:clrMapOvr>
-</p:notes>
-</file>
-
-<file path=ppt/notesSlides/notesSlide9.xml><?xml version="1.0" encoding="utf-8"?>
-<p:notes xmlns:a="http://schemas.openxmlformats.org/drawingml/2006/main" xmlns:p="http://schemas.openxmlformats.org/presentationml/2006/main" xmlns:r="http://schemas.openxmlformats.org/officeDocument/2006/relationships">
-  <p:cSld>
-    <p:spTree>
-      <p:nvGrpSpPr>
-        <p:cNvPr id="1" name=""/>
-        <p:cNvGrpSpPr/>
-        <p:nvPr/>
-      </p:nvGrpSpPr>
-      <p:grpSpPr>
-        <a:xfrm>
-          <a:off x="0" y="0"/>
-          <a:ext cx="0" cy="0"/>
-          <a:chOff x="0" y="0"/>
-          <a:chExt cx="0" cy="0"/>
-        </a:xfrm>
-      </p:grpSpPr>
-      <p:sp>
-        <p:nvSpPr>
-          <p:cNvPr id="2" name="Slide Image Placeholder 1"/>
-          <p:cNvSpPr>
-            <a:spLocks noGrp="1"/>
-          </p:cNvSpPr>
-          <p:nvPr>
-            <p:ph type="sldImg" idx="2"/>
-          </p:nvPr>
-        </p:nvSpPr>
-        <p:spPr/>
-      </p:sp>
-      <p:sp>
-        <p:nvSpPr>
-          <p:cNvPr id="3" name="Notes Placeholder 2"/>
-          <p:cNvSpPr>
-            <a:spLocks noGrp="1"/>
-          </p:cNvSpPr>
-          <p:nvPr>
-            <p:ph type="body" idx="3" sz="quarter"/>
-          </p:nvPr>
-        </p:nvSpPr>
-        <p:spPr/>
-        <p:txBody>
-          <a:bodyPr/>
-          <a:lstStyle/>
-          <a:p>
-            <a:r>
-              <a:t>Teams make their copy now, if they did not before the session. The README has the steps. Walk the room: the usual problems are Python not on the PATH on Windows (`python` instead of `python3`) and the venv not activated. Each team ingests one published source of its own and reads the source page back.</a:t>
+              <a:t>The first evaluation is held against the PRD's own criteria, and the decision log travels with it. The lookup record and the quotation check are what let a team explain a wrong sentence on its page instead of guessing.</a:t>
             </a:r>
           </a:p>
         </p:txBody>
@@ -4359,7 +4043,7 @@
                   <a:srgbClr val="6B7280"/>
                 </a:solidFill>
               </a:rPr>
-              <a:t>1 / 11</a:t>
+              <a:t>1 / 6</a:t>
             </a:r>
           </a:p>
         </p:txBody>
@@ -4431,682 +4115,6 @@
                 </a:solidFill>
               </a:rPr>
               <a:t>Week 5.</a:t>
-            </a:r>
-          </a:p>
-        </p:txBody>
-      </p:sp>
-      <p:sp>
-        <p:nvSpPr>
-          <p:cNvPr id="7" name="TextBox 6"/>
-          <p:cNvSpPr txBox="1"/>
-          <p:nvPr/>
-        </p:nvSpPr>
-        <p:spPr>
-          <a:xfrm>
-            <a:off x="731520" y="6309360"/>
-            <a:ext cx="7315200" cy="320040"/>
-          </a:xfrm>
-          <a:prstGeom prst="rect">
-            <a:avLst/>
-          </a:prstGeom>
-          <a:noFill/>
-        </p:spPr>
-        <p:txBody>
-          <a:bodyPr wrap="square">
-            <a:spAutoFit/>
-          </a:bodyPr>
-          <a:lstStyle/>
-          <a:p>
-            <a:r>
-              <a:rPr sz="900">
-                <a:solidFill>
-                  <a:srgbClr val="6B7280"/>
-                </a:solidFill>
-              </a:rPr>
-              <a:t>AI in Business · week 5</a:t>
-            </a:r>
-          </a:p>
-        </p:txBody>
-      </p:sp>
-    </p:spTree>
-  </p:cSld>
-  <p:clrMapOvr>
-    <a:masterClrMapping/>
-  </p:clrMapOvr>
-</p:sld>
-</file>
-
-<file path=ppt/slides/slide10.xml><?xml version="1.0" encoding="utf-8"?>
-<p:sld xmlns:a="http://schemas.openxmlformats.org/drawingml/2006/main" xmlns:p="http://schemas.openxmlformats.org/presentationml/2006/main" xmlns:r="http://schemas.openxmlformats.org/officeDocument/2006/relationships">
-  <p:cSld>
-    <p:spTree>
-      <p:nvGrpSpPr>
-        <p:cNvPr id="1" name=""/>
-        <p:cNvGrpSpPr/>
-        <p:nvPr/>
-      </p:nvGrpSpPr>
-      <p:grpSpPr/>
-      <p:sp>
-        <p:nvSpPr>
-          <p:cNvPr id="2" name="Rectangle 1"/>
-          <p:cNvSpPr/>
-          <p:nvPr/>
-        </p:nvSpPr>
-        <p:spPr>
-          <a:xfrm>
-            <a:off x="731520" y="566928"/>
-            <a:ext cx="320040" cy="73152"/>
-          </a:xfrm>
-          <a:prstGeom prst="rect">
-            <a:avLst/>
-          </a:prstGeom>
-          <a:solidFill>
-            <a:srgbClr val="D4DB3E"/>
-          </a:solidFill>
-          <a:ln>
-            <a:noFill/>
-          </a:ln>
-        </p:spPr>
-        <p:style>
-          <a:lnRef idx="1">
-            <a:schemeClr val="accent1"/>
-          </a:lnRef>
-          <a:fillRef idx="3">
-            <a:schemeClr val="accent1"/>
-          </a:fillRef>
-          <a:effectRef idx="2">
-            <a:schemeClr val="accent1"/>
-          </a:effectRef>
-          <a:fontRef idx="minor">
-            <a:schemeClr val="lt1"/>
-          </a:fontRef>
-        </p:style>
-        <p:txBody>
-          <a:bodyPr rtlCol="0" anchor="ctr"/>
-          <a:lstStyle/>
-          <a:p>
-            <a:pPr algn="ctr"/>
-          </a:p>
-        </p:txBody>
-      </p:sp>
-      <p:sp>
-        <p:nvSpPr>
-          <p:cNvPr id="3" name="TextBox 2"/>
-          <p:cNvSpPr txBox="1"/>
-          <p:nvPr/>
-        </p:nvSpPr>
-        <p:spPr>
-          <a:xfrm>
-            <a:off x="1143000" y="411480"/>
-            <a:ext cx="7315200" cy="365760"/>
-          </a:xfrm>
-          <a:prstGeom prst="rect">
-            <a:avLst/>
-          </a:prstGeom>
-          <a:noFill/>
-        </p:spPr>
-        <p:txBody>
-          <a:bodyPr wrap="square">
-            <a:spAutoFit/>
-          </a:bodyPr>
-          <a:lstStyle/>
-          <a:p>
-            <a:r>
-              <a:rPr sz="1100" b="1">
-                <a:solidFill>
-                  <a:srgbClr val="1A1A1A"/>
-                </a:solidFill>
-              </a:rPr>
-              <a:t>YOURS TO TAKE</a:t>
-            </a:r>
-          </a:p>
-        </p:txBody>
-      </p:sp>
-      <p:sp>
-        <p:nvSpPr>
-          <p:cNvPr id="4" name="TextBox 3"/>
-          <p:cNvSpPr txBox="1"/>
-          <p:nvPr/>
-        </p:nvSpPr>
-        <p:spPr>
-          <a:xfrm>
-            <a:off x="9601200" y="411480"/>
-            <a:ext cx="1828800" cy="365760"/>
-          </a:xfrm>
-          <a:prstGeom prst="rect">
-            <a:avLst/>
-          </a:prstGeom>
-          <a:noFill/>
-        </p:spPr>
-        <p:txBody>
-          <a:bodyPr wrap="square">
-            <a:spAutoFit/>
-          </a:bodyPr>
-          <a:lstStyle/>
-          <a:p>
-            <a:pPr algn="r"/>
-            <a:r>
-              <a:rPr sz="1100">
-                <a:solidFill>
-                  <a:srgbClr val="6B7280"/>
-                </a:solidFill>
-              </a:rPr>
-              <a:t>10 / 11</a:t>
-            </a:r>
-          </a:p>
-        </p:txBody>
-      </p:sp>
-      <p:sp>
-        <p:nvSpPr>
-          <p:cNvPr id="5" name="TextBox 4"/>
-          <p:cNvSpPr txBox="1"/>
-          <p:nvPr/>
-        </p:nvSpPr>
-        <p:spPr>
-          <a:xfrm>
-            <a:off x="731520" y="914400"/>
-            <a:ext cx="10698480" cy="1188720"/>
-          </a:xfrm>
-          <a:prstGeom prst="rect">
-            <a:avLst/>
-          </a:prstGeom>
-          <a:noFill/>
-        </p:spPr>
-        <p:txBody>
-          <a:bodyPr wrap="square">
-            <a:spAutoFit/>
-          </a:bodyPr>
-          <a:lstStyle/>
-          <a:p>
-            <a:r>
-              <a:rPr sz="3200" b="1">
-                <a:solidFill>
-                  <a:srgbClr val="111827"/>
-                </a:solidFill>
-              </a:rPr>
-              <a:t>Adopting the wiki is a decision, and it has costs</a:t>
-            </a:r>
-          </a:p>
-        </p:txBody>
-      </p:sp>
-      <p:sp>
-        <p:nvSpPr>
-          <p:cNvPr id="6" name="TextBox 5"/>
-          <p:cNvSpPr txBox="1"/>
-          <p:nvPr/>
-        </p:nvSpPr>
-        <p:spPr>
-          <a:xfrm>
-            <a:off x="731520" y="2103120"/>
-            <a:ext cx="10698480" cy="3931920"/>
-          </a:xfrm>
-          <a:prstGeom prst="rect">
-            <a:avLst/>
-          </a:prstGeom>
-          <a:noFill/>
-        </p:spPr>
-        <p:txBody>
-          <a:bodyPr wrap="square">
-            <a:spAutoFit/>
-          </a:bodyPr>
-          <a:lstStyle/>
-          <a:p>
-            <a:pPr>
-              <a:spcAft>
-                <a:spcPts val="800"/>
-              </a:spcAft>
-            </a:pPr>
-            <a:r>
-              <a:rPr sz="1800">
-                <a:solidFill>
-                  <a:srgbClr val="111827"/>
-                </a:solidFill>
-              </a:rPr>
-              <a:t>•  </a:t>
-            </a:r>
-            <a:r>
-              <a:rPr sz="1800" b="1">
-                <a:solidFill>
-                  <a:srgbClr val="111827"/>
-                </a:solidFill>
-              </a:rPr>
-              <a:t>Reading up front.</a:t>
-            </a:r>
-            <a:r>
-              <a:rPr sz="1800">
-                <a:solidFill>
-                  <a:srgbClr val="111827"/>
-                </a:solidFill>
-              </a:rPr>
-              <a:t> Every source costs model time.</a:t>
-            </a:r>
-          </a:p>
-          <a:p>
-            <a:pPr>
-              <a:spcAft>
-                <a:spcPts val="800"/>
-              </a:spcAft>
-            </a:pPr>
-            <a:r>
-              <a:rPr sz="1800">
-                <a:solidFill>
-                  <a:srgbClr val="111827"/>
-                </a:solidFill>
-              </a:rPr>
-              <a:t>•  </a:t>
-            </a:r>
-            <a:r>
-              <a:rPr sz="1800" b="1">
-                <a:solidFill>
-                  <a:srgbClr val="111827"/>
-                </a:solidFill>
-              </a:rPr>
-              <a:t>A misreading spreads.</a:t>
-            </a:r>
-            <a:r>
-              <a:rPr sz="1800">
-                <a:solidFill>
-                  <a:srgbClr val="111827"/>
-                </a:solidFill>
-              </a:rPr>
-              <a:t> Several pages at once.</a:t>
-            </a:r>
-          </a:p>
-          <a:p>
-            <a:pPr>
-              <a:spcAft>
-                <a:spcPts val="800"/>
-              </a:spcAft>
-            </a:pPr>
-            <a:r>
-              <a:rPr sz="1800">
-                <a:solidFill>
-                  <a:srgbClr val="111827"/>
-                </a:solidFill>
-              </a:rPr>
-              <a:t>•  </a:t>
-            </a:r>
-            <a:r>
-              <a:rPr sz="1800" b="1">
-                <a:solidFill>
-                  <a:srgbClr val="111827"/>
-                </a:solidFill>
-              </a:rPr>
-              <a:t>A few hundred pages.</a:t>
-            </a:r>
-            <a:r>
-              <a:rPr sz="1800">
-                <a:solidFill>
-                  <a:srgbClr val="111827"/>
-                </a:solidFill>
-              </a:rPr>
-              <a:t> Then you need search.</a:t>
-            </a:r>
-          </a:p>
-          <a:p>
-            <a:pPr>
-              <a:spcAft>
-                <a:spcPts val="800"/>
-              </a:spcAft>
-            </a:pPr>
-            <a:r>
-              <a:rPr sz="1800">
-                <a:solidFill>
-                  <a:srgbClr val="111827"/>
-                </a:solidFill>
-              </a:rPr>
-              <a:t>Adopting it? An entry in your </a:t>
-            </a:r>
-            <a:r>
-              <a:rPr sz="1800">
-                <a:solidFill>
-                  <a:srgbClr val="111827"/>
-                </a:solidFill>
-                <a:hlinkClick r:id="rId2"/>
-              </a:rPr>
-              <a:t>decision log</a:t>
-            </a:r>
-            <a:r>
-              <a:rPr sz="1800">
-                <a:solidFill>
-                  <a:srgbClr val="111827"/>
-                </a:solidFill>
-              </a:rPr>
-              <a:t>.</a:t>
-            </a:r>
-          </a:p>
-        </p:txBody>
-      </p:sp>
-      <p:sp>
-        <p:nvSpPr>
-          <p:cNvPr id="7" name="TextBox 6"/>
-          <p:cNvSpPr txBox="1"/>
-          <p:nvPr/>
-        </p:nvSpPr>
-        <p:spPr>
-          <a:xfrm>
-            <a:off x="731520" y="6309360"/>
-            <a:ext cx="7315200" cy="320040"/>
-          </a:xfrm>
-          <a:prstGeom prst="rect">
-            <a:avLst/>
-          </a:prstGeom>
-          <a:noFill/>
-        </p:spPr>
-        <p:txBody>
-          <a:bodyPr wrap="square">
-            <a:spAutoFit/>
-          </a:bodyPr>
-          <a:lstStyle/>
-          <a:p>
-            <a:r>
-              <a:rPr sz="900">
-                <a:solidFill>
-                  <a:srgbClr val="6B7280"/>
-                </a:solidFill>
-              </a:rPr>
-              <a:t>AI in Business · week 5</a:t>
-            </a:r>
-          </a:p>
-        </p:txBody>
-      </p:sp>
-    </p:spTree>
-  </p:cSld>
-  <p:clrMapOvr>
-    <a:masterClrMapping/>
-  </p:clrMapOvr>
-</p:sld>
-</file>
-
-<file path=ppt/slides/slide11.xml><?xml version="1.0" encoding="utf-8"?>
-<p:sld xmlns:a="http://schemas.openxmlformats.org/drawingml/2006/main" xmlns:p="http://schemas.openxmlformats.org/presentationml/2006/main" xmlns:r="http://schemas.openxmlformats.org/officeDocument/2006/relationships">
-  <p:cSld>
-    <p:spTree>
-      <p:nvGrpSpPr>
-        <p:cNvPr id="1" name=""/>
-        <p:cNvGrpSpPr/>
-        <p:nvPr/>
-      </p:nvGrpSpPr>
-      <p:grpSpPr/>
-      <p:sp>
-        <p:nvSpPr>
-          <p:cNvPr id="2" name="Rectangle 1"/>
-          <p:cNvSpPr/>
-          <p:nvPr/>
-        </p:nvSpPr>
-        <p:spPr>
-          <a:xfrm>
-            <a:off x="731520" y="566928"/>
-            <a:ext cx="320040" cy="73152"/>
-          </a:xfrm>
-          <a:prstGeom prst="rect">
-            <a:avLst/>
-          </a:prstGeom>
-          <a:solidFill>
-            <a:srgbClr val="D4DB3E"/>
-          </a:solidFill>
-          <a:ln>
-            <a:noFill/>
-          </a:ln>
-        </p:spPr>
-        <p:style>
-          <a:lnRef idx="1">
-            <a:schemeClr val="accent1"/>
-          </a:lnRef>
-          <a:fillRef idx="3">
-            <a:schemeClr val="accent1"/>
-          </a:fillRef>
-          <a:effectRef idx="2">
-            <a:schemeClr val="accent1"/>
-          </a:effectRef>
-          <a:fontRef idx="minor">
-            <a:schemeClr val="lt1"/>
-          </a:fontRef>
-        </p:style>
-        <p:txBody>
-          <a:bodyPr rtlCol="0" anchor="ctr"/>
-          <a:lstStyle/>
-          <a:p>
-            <a:pPr algn="ctr"/>
-          </a:p>
-        </p:txBody>
-      </p:sp>
-      <p:sp>
-        <p:nvSpPr>
-          <p:cNvPr id="3" name="TextBox 2"/>
-          <p:cNvSpPr txBox="1"/>
-          <p:nvPr/>
-        </p:nvSpPr>
-        <p:spPr>
-          <a:xfrm>
-            <a:off x="1143000" y="411480"/>
-            <a:ext cx="7315200" cy="365760"/>
-          </a:xfrm>
-          <a:prstGeom prst="rect">
-            <a:avLst/>
-          </a:prstGeom>
-          <a:noFill/>
-        </p:spPr>
-        <p:txBody>
-          <a:bodyPr wrap="square">
-            <a:spAutoFit/>
-          </a:bodyPr>
-          <a:lstStyle/>
-          <a:p>
-            <a:r>
-              <a:rPr sz="1100" b="1">
-                <a:solidFill>
-                  <a:srgbClr val="1A1A1A"/>
-                </a:solidFill>
-              </a:rPr>
-              <a:t>HOMEWORK</a:t>
-            </a:r>
-          </a:p>
-        </p:txBody>
-      </p:sp>
-      <p:sp>
-        <p:nvSpPr>
-          <p:cNvPr id="4" name="TextBox 3"/>
-          <p:cNvSpPr txBox="1"/>
-          <p:nvPr/>
-        </p:nvSpPr>
-        <p:spPr>
-          <a:xfrm>
-            <a:off x="9601200" y="411480"/>
-            <a:ext cx="1828800" cy="365760"/>
-          </a:xfrm>
-          <a:prstGeom prst="rect">
-            <a:avLst/>
-          </a:prstGeom>
-          <a:noFill/>
-        </p:spPr>
-        <p:txBody>
-          <a:bodyPr wrap="square">
-            <a:spAutoFit/>
-          </a:bodyPr>
-          <a:lstStyle/>
-          <a:p>
-            <a:pPr algn="r"/>
-            <a:r>
-              <a:rPr sz="1100">
-                <a:solidFill>
-                  <a:srgbClr val="6B7280"/>
-                </a:solidFill>
-              </a:rPr>
-              <a:t>11 / 11</a:t>
-            </a:r>
-          </a:p>
-        </p:txBody>
-      </p:sp>
-      <p:sp>
-        <p:nvSpPr>
-          <p:cNvPr id="5" name="TextBox 4"/>
-          <p:cNvSpPr txBox="1"/>
-          <p:nvPr/>
-        </p:nvSpPr>
-        <p:spPr>
-          <a:xfrm>
-            <a:off x="731520" y="914400"/>
-            <a:ext cx="10698480" cy="1188720"/>
-          </a:xfrm>
-          <a:prstGeom prst="rect">
-            <a:avLst/>
-          </a:prstGeom>
-          <a:noFill/>
-        </p:spPr>
-        <p:txBody>
-          <a:bodyPr wrap="square">
-            <a:spAutoFit/>
-          </a:bodyPr>
-          <a:lstStyle/>
-          <a:p>
-            <a:r>
-              <a:rPr sz="3200" b="1">
-                <a:solidFill>
-                  <a:srgbClr val="111827"/>
-                </a:solidFill>
-              </a:rPr>
-              <a:t>Before 12 October: the first evaluation, with your decision log</a:t>
-            </a:r>
-          </a:p>
-        </p:txBody>
-      </p:sp>
-      <p:sp>
-        <p:nvSpPr>
-          <p:cNvPr id="6" name="TextBox 5"/>
-          <p:cNvSpPr txBox="1"/>
-          <p:nvPr/>
-        </p:nvSpPr>
-        <p:spPr>
-          <a:xfrm>
-            <a:off x="731520" y="2103120"/>
-            <a:ext cx="10698480" cy="3931920"/>
-          </a:xfrm>
-          <a:prstGeom prst="rect">
-            <a:avLst/>
-          </a:prstGeom>
-          <a:noFill/>
-        </p:spPr>
-        <p:txBody>
-          <a:bodyPr wrap="square">
-            <a:spAutoFit/>
-          </a:bodyPr>
-          <a:lstStyle/>
-          <a:p>
-            <a:pPr>
-              <a:spcAft>
-                <a:spcPts val="800"/>
-              </a:spcAft>
-            </a:pPr>
-            <a:r>
-              <a:rPr sz="1800">
-                <a:solidFill>
-                  <a:srgbClr val="111827"/>
-                </a:solidFill>
-                <a:hlinkClick r:id="rId2"/>
-              </a:rPr>
-              <a:t>The assignment is here</a:t>
-            </a:r>
-            <a:r>
-              <a:rPr sz="1800">
-                <a:solidFill>
-                  <a:srgbClr val="111827"/>
-                </a:solidFill>
-              </a:rPr>
-              <a:t>.</a:t>
-            </a:r>
-          </a:p>
-          <a:p>
-            <a:pPr>
-              <a:spcAft>
-                <a:spcPts val="800"/>
-              </a:spcAft>
-            </a:pPr>
-            <a:r>
-              <a:rPr sz="1800">
-                <a:solidFill>
-                  <a:srgbClr val="111827"/>
-                </a:solidFill>
-              </a:rPr>
-              <a:t>•  </a:t>
-            </a:r>
-            <a:r>
-              <a:rPr sz="1800" b="1">
-                <a:solidFill>
-                  <a:srgbClr val="111827"/>
-                </a:solidFill>
-              </a:rPr>
-              <a:t>Held against</a:t>
-            </a:r>
-            <a:r>
-              <a:rPr sz="1800">
-                <a:solidFill>
-                  <a:srgbClr val="111827"/>
-                </a:solidFill>
-              </a:rPr>
-              <a:t> your PRD’s criteria.</a:t>
-            </a:r>
-          </a:p>
-          <a:p>
-            <a:pPr>
-              <a:spcAft>
-                <a:spcPts val="800"/>
-              </a:spcAft>
-            </a:pPr>
-            <a:r>
-              <a:rPr sz="1800">
-                <a:solidFill>
-                  <a:srgbClr val="111827"/>
-                </a:solidFill>
-              </a:rPr>
-              <a:t>•  </a:t>
-            </a:r>
-            <a:r>
-              <a:rPr sz="1800" b="1">
-                <a:solidFill>
-                  <a:srgbClr val="111827"/>
-                </a:solidFill>
-              </a:rPr>
-              <a:t>A record</a:t>
-            </a:r>
-            <a:r>
-              <a:rPr sz="1800">
-                <a:solidFill>
-                  <a:srgbClr val="111827"/>
-                </a:solidFill>
-              </a:rPr>
-              <a:t> of each lookup.</a:t>
-            </a:r>
-          </a:p>
-          <a:p>
-            <a:pPr>
-              <a:spcAft>
-                <a:spcPts val="800"/>
-              </a:spcAft>
-            </a:pPr>
-            <a:r>
-              <a:rPr sz="1800">
-                <a:solidFill>
-                  <a:srgbClr val="111827"/>
-                </a:solidFill>
-              </a:rPr>
-              <a:t>•  </a:t>
-            </a:r>
-            <a:r>
-              <a:rPr sz="1800" b="1">
-                <a:solidFill>
-                  <a:srgbClr val="111827"/>
-                </a:solidFill>
-              </a:rPr>
-              <a:t>Every quotation</a:t>
-            </a:r>
-            <a:r>
-              <a:rPr sz="1800">
-                <a:solidFill>
-                  <a:srgbClr val="111827"/>
-                </a:solidFill>
-              </a:rPr>
-              <a:t> checked against its source.</a:t>
             </a:r>
           </a:p>
         </p:txBody>
@@ -5267,7 +4275,7 @@
                   <a:srgbClr val="6B7280"/>
                 </a:solidFill>
               </a:rPr>
-              <a:t>2 / 11</a:t>
+              <a:t>2 / 6</a:t>
             </a:r>
           </a:p>
         </p:txBody>
@@ -5499,7 +4507,7 @@
                   <a:srgbClr val="6B7280"/>
                 </a:solidFill>
               </a:rPr>
-              <a:t>3 / 11</a:t>
+              <a:t>3 / 6</a:t>
             </a:r>
           </a:p>
         </p:txBody>
@@ -5532,7 +4540,7 @@
                   <a:srgbClr val="111827"/>
                 </a:solidFill>
               </a:rPr>
-              <a:t>Most tools read your sources again for every question</a:t>
+              <a:t>An LLM wiki reads each source once and keeps what it read</a:t>
             </a:r>
           </a:p>
         </p:txBody>
@@ -5546,7 +4554,7 @@
         <p:spPr>
           <a:xfrm>
             <a:off x="731520" y="2103120"/>
-            <a:ext cx="10698480" cy="3931920"/>
+            <a:ext cx="3261360" cy="3931920"/>
           </a:xfrm>
           <a:prstGeom prst="rect">
             <a:avLst/>
@@ -5565,12 +4573,12 @@
               </a:spcAft>
             </a:pPr>
             <a:r>
-              <a:rPr sz="1800">
-                <a:solidFill>
-                  <a:srgbClr val="111827"/>
+              <a:rPr sz="1100" b="1">
+                <a:solidFill>
+                  <a:srgbClr val="4B5563"/>
                 </a:solidFill>
               </a:rPr>
-              <a:t>“The LLM is rediscovering knowledge from scratch on every question.”</a:t>
+              <a:t>RAW/</a:t>
             </a:r>
           </a:p>
           <a:p>
@@ -5585,8 +4593,121 @@
                   <a:srgbClr val="111827"/>
                 </a:solidFill>
               </a:rPr>
-              <a:t>Andrej Karpathy, </a:t>
-            </a:r>
+              <a:t>The sources. Never edited.</a:t>
+            </a:r>
+          </a:p>
+        </p:txBody>
+      </p:sp>
+      <p:sp>
+        <p:nvSpPr>
+          <p:cNvPr id="7" name="TextBox 6"/>
+          <p:cNvSpPr txBox="1"/>
+          <p:nvPr/>
+        </p:nvSpPr>
+        <p:spPr>
+          <a:xfrm>
+            <a:off x="4450080" y="2103120"/>
+            <a:ext cx="3261360" cy="3931920"/>
+          </a:xfrm>
+          <a:prstGeom prst="rect">
+            <a:avLst/>
+          </a:prstGeom>
+          <a:noFill/>
+        </p:spPr>
+        <p:txBody>
+          <a:bodyPr wrap="square">
+            <a:spAutoFit/>
+          </a:bodyPr>
+          <a:lstStyle/>
+          <a:p>
+            <a:pPr>
+              <a:spcAft>
+                <a:spcPts val="800"/>
+              </a:spcAft>
+            </a:pPr>
+            <a:r>
+              <a:rPr sz="1100" b="1">
+                <a:solidFill>
+                  <a:srgbClr val="4B5563"/>
+                </a:solidFill>
+              </a:rPr>
+              <a:t>WIKI/</a:t>
+            </a:r>
+          </a:p>
+          <a:p>
+            <a:pPr>
+              <a:spcAft>
+                <a:spcPts val="800"/>
+              </a:spcAft>
+            </a:pPr>
+            <a:r>
+              <a:rPr sz="1800">
+                <a:solidFill>
+                  <a:srgbClr val="111827"/>
+                </a:solidFill>
+              </a:rPr>
+              <a:t>The pages. The assistant writes.</a:t>
+            </a:r>
+          </a:p>
+        </p:txBody>
+      </p:sp>
+      <p:sp>
+        <p:nvSpPr>
+          <p:cNvPr id="8" name="TextBox 7"/>
+          <p:cNvSpPr txBox="1"/>
+          <p:nvPr/>
+        </p:nvSpPr>
+        <p:spPr>
+          <a:xfrm>
+            <a:off x="8168640" y="2103120"/>
+            <a:ext cx="3261360" cy="3931920"/>
+          </a:xfrm>
+          <a:prstGeom prst="rect">
+            <a:avLst/>
+          </a:prstGeom>
+          <a:noFill/>
+        </p:spPr>
+        <p:txBody>
+          <a:bodyPr wrap="square">
+            <a:spAutoFit/>
+          </a:bodyPr>
+          <a:lstStyle/>
+          <a:p>
+            <a:pPr>
+              <a:spcAft>
+                <a:spcPts val="800"/>
+              </a:spcAft>
+            </a:pPr>
+            <a:r>
+              <a:rPr sz="1100" b="1">
+                <a:solidFill>
+                  <a:srgbClr val="4B5563"/>
+                </a:solidFill>
+              </a:rPr>
+              <a:t>AGENTS.MD</a:t>
+            </a:r>
+          </a:p>
+          <a:p>
+            <a:pPr>
+              <a:spcAft>
+                <a:spcPts val="800"/>
+              </a:spcAft>
+            </a:pPr>
+            <a:r>
+              <a:rPr sz="1800">
+                <a:solidFill>
+                  <a:srgbClr val="111827"/>
+                </a:solidFill>
+              </a:rPr>
+              <a:t>The rules. You change them.</a:t>
+            </a:r>
+          </a:p>
+          <a:p>
+            <a:pPr>
+              <a:spcAft>
+                <a:spcPts val="800"/>
+              </a:spcAft>
+            </a:pPr>
             <a:r>
               <a:rPr sz="1800">
                 <a:solidFill>
@@ -5594,7 +4715,7 @@
                 </a:solidFill>
                 <a:hlinkClick r:id="rId2"/>
               </a:rPr>
-              <a:t>LLM Wiki</a:t>
+              <a:t>Karpathy, LLM Wiki</a:t>
             </a:r>
             <a:r>
               <a:rPr sz="1800">
@@ -5602,31 +4723,14 @@
                   <a:srgbClr val="111827"/>
                 </a:solidFill>
               </a:rPr>
-              <a:t>, April 2026. Week 3: </a:t>
-            </a:r>
-            <a:r>
-              <a:rPr sz="1800">
-                <a:solidFill>
-                  <a:srgbClr val="111827"/>
-                </a:solidFill>
-                <a:hlinkClick r:id="rId3"/>
-              </a:rPr>
-              <a:t>one question, four ways</a:t>
-            </a:r>
-            <a:r>
-              <a:rPr sz="1800">
-                <a:solidFill>
-                  <a:srgbClr val="111827"/>
-                </a:solidFill>
-              </a:rPr>
-              <a:t>.</a:t>
-            </a:r>
-          </a:p>
-        </p:txBody>
-      </p:sp>
-      <p:sp>
-        <p:nvSpPr>
-          <p:cNvPr id="7" name="TextBox 6"/>
+              <a:t>, April 2026.</a:t>
+            </a:r>
+          </a:p>
+        </p:txBody>
+      </p:sp>
+      <p:sp>
+        <p:nvSpPr>
+          <p:cNvPr id="9" name="TextBox 8"/>
           <p:cNvSpPr txBox="1"/>
           <p:nvPr/>
         </p:nvSpPr>
@@ -5746,7 +4850,7 @@
                   <a:srgbClr val="1A1A1A"/>
                 </a:solidFill>
               </a:rPr>
-              <a:t>KNOWLEDGE ARCHITECTURE</a:t>
+              <a:t>LIVE DEMO</a:t>
             </a:r>
           </a:p>
         </p:txBody>
@@ -5780,7 +4884,7 @@
                   <a:srgbClr val="6B7280"/>
                 </a:solidFill>
               </a:rPr>
-              <a:t>4 / 11</a:t>
+              <a:t>4 / 6</a:t>
             </a:r>
           </a:p>
         </p:txBody>
@@ -5813,7 +4917,7 @@
                   <a:srgbClr val="111827"/>
                 </a:solidFill>
               </a:rPr>
-              <a:t>An LLM wiki reads each source once and keeps what it read</a:t>
+              <a:t>Three sources, three formats, one empty wiki</a:t>
             </a:r>
           </a:p>
         </p:txBody>
@@ -5827,7 +4931,7 @@
         <p:spPr>
           <a:xfrm>
             <a:off x="731520" y="2103120"/>
-            <a:ext cx="3261360" cy="3931920"/>
+            <a:ext cx="10698480" cy="3931920"/>
           </a:xfrm>
           <a:prstGeom prst="rect">
             <a:avLst/>
@@ -5846,12 +4950,45 @@
               </a:spcAft>
             </a:pPr>
             <a:r>
-              <a:rPr sz="1100" b="1">
-                <a:solidFill>
-                  <a:srgbClr val="4B5563"/>
+              <a:rPr sz="1800">
+                <a:solidFill>
+                  <a:srgbClr val="111827"/>
                 </a:solidFill>
               </a:rPr>
-              <a:t>RAW/</a:t>
+              <a:t>•  </a:t>
+            </a:r>
+            <a:r>
+              <a:rPr sz="1800" b="1">
+                <a:solidFill>
+                  <a:srgbClr val="111827"/>
+                </a:solidFill>
+              </a:rPr>
+              <a:t>Article.</a:t>
+            </a:r>
+            <a:r>
+              <a:rPr sz="1800">
+                <a:solidFill>
+                  <a:srgbClr val="111827"/>
+                </a:solidFill>
+              </a:rPr>
+              <a:t> </a:t>
+            </a:r>
+            <a:r>
+              <a:rPr sz="1800">
+                <a:solidFill>
+                  <a:srgbClr val="111827"/>
+                </a:solidFill>
+                <a:hlinkClick r:id="rId2"/>
+              </a:rPr>
+              <a:t>OECD Cogito blog</a:t>
+            </a:r>
+            <a:r>
+              <a:rPr sz="1800">
+                <a:solidFill>
+                  <a:srgbClr val="111827"/>
+                </a:solidFill>
+              </a:rPr>
+              <a:t>, 2025.</a:t>
             </a:r>
           </a:p>
           <a:p>
@@ -5866,32 +5003,42 @@
                   <a:srgbClr val="111827"/>
                 </a:solidFill>
               </a:rPr>
-              <a:t>The sources. You add them; nobody edits them.</a:t>
-            </a:r>
-          </a:p>
-        </p:txBody>
-      </p:sp>
-      <p:sp>
-        <p:nvSpPr>
-          <p:cNvPr id="7" name="TextBox 6"/>
-          <p:cNvSpPr txBox="1"/>
-          <p:nvPr/>
-        </p:nvSpPr>
-        <p:spPr>
-          <a:xfrm>
-            <a:off x="4450080" y="2103120"/>
-            <a:ext cx="3261360" cy="3931920"/>
-          </a:xfrm>
-          <a:prstGeom prst="rect">
-            <a:avLst/>
-          </a:prstGeom>
-          <a:noFill/>
-        </p:spPr>
-        <p:txBody>
-          <a:bodyPr wrap="square">
-            <a:spAutoFit/>
-          </a:bodyPr>
-          <a:lstStyle/>
+              <a:t>•  </a:t>
+            </a:r>
+            <a:r>
+              <a:rPr sz="1800" b="1">
+                <a:solidFill>
+                  <a:srgbClr val="111827"/>
+                </a:solidFill>
+              </a:rPr>
+              <a:t>Video.</a:t>
+            </a:r>
+            <a:r>
+              <a:rPr sz="1800">
+                <a:solidFill>
+                  <a:srgbClr val="111827"/>
+                </a:solidFill>
+              </a:rPr>
+              <a:t> </a:t>
+            </a:r>
+            <a:r>
+              <a:rPr sz="1800">
+                <a:solidFill>
+                  <a:srgbClr val="111827"/>
+                </a:solidFill>
+                <a:hlinkClick r:id="rId3"/>
+              </a:rPr>
+              <a:t>Asian Productivity Organization</a:t>
+            </a:r>
+            <a:r>
+              <a:rPr sz="1800">
+                <a:solidFill>
+                  <a:srgbClr val="111827"/>
+                </a:solidFill>
+              </a:rPr>
+              <a:t>, 64 minutes.</a:t>
+            </a:r>
+          </a:p>
           <a:p>
             <a:pPr>
               <a:spcAft>
@@ -5899,87 +5046,52 @@
               </a:spcAft>
             </a:pPr>
             <a:r>
-              <a:rPr sz="1100" b="1">
-                <a:solidFill>
-                  <a:srgbClr val="4B5563"/>
+              <a:rPr sz="1800">
+                <a:solidFill>
+                  <a:srgbClr val="111827"/>
                 </a:solidFill>
               </a:rPr>
-              <a:t>WIKI/</a:t>
-            </a:r>
-          </a:p>
-          <a:p>
-            <a:pPr>
-              <a:spcAft>
-                <a:spcPts val="800"/>
-              </a:spcAft>
-            </a:pPr>
+              <a:t>•  </a:t>
+            </a:r>
+            <a:r>
+              <a:rPr sz="1800" b="1">
+                <a:solidFill>
+                  <a:srgbClr val="111827"/>
+                </a:solidFill>
+              </a:rPr>
+              <a:t>Report.</a:t>
+            </a:r>
             <a:r>
               <a:rPr sz="1800">
                 <a:solidFill>
                   <a:srgbClr val="111827"/>
                 </a:solidFill>
               </a:rPr>
-              <a:t>The pages. The assistant writes; you check.</a:t>
-            </a:r>
-          </a:p>
-        </p:txBody>
-      </p:sp>
-      <p:sp>
-        <p:nvSpPr>
-          <p:cNvPr id="8" name="TextBox 7"/>
-          <p:cNvSpPr txBox="1"/>
-          <p:nvPr/>
-        </p:nvSpPr>
-        <p:spPr>
-          <a:xfrm>
-            <a:off x="8168640" y="2103120"/>
-            <a:ext cx="3261360" cy="3931920"/>
-          </a:xfrm>
-          <a:prstGeom prst="rect">
-            <a:avLst/>
-          </a:prstGeom>
-          <a:noFill/>
-        </p:spPr>
-        <p:txBody>
-          <a:bodyPr wrap="square">
-            <a:spAutoFit/>
-          </a:bodyPr>
-          <a:lstStyle/>
-          <a:p>
-            <a:pPr>
-              <a:spcAft>
-                <a:spcPts val="800"/>
-              </a:spcAft>
-            </a:pPr>
-            <a:r>
-              <a:rPr sz="1100" b="1">
-                <a:solidFill>
-                  <a:srgbClr val="4B5563"/>
-                </a:solidFill>
+              <a:t> </a:t>
+            </a:r>
+            <a:r>
+              <a:rPr sz="1800">
+                <a:solidFill>
+                  <a:srgbClr val="111827"/>
+                </a:solidFill>
+                <a:hlinkClick r:id="rId4"/>
               </a:rPr>
-              <a:t>AGENTS.MD</a:t>
-            </a:r>
-          </a:p>
-          <a:p>
-            <a:pPr>
-              <a:spcAft>
-                <a:spcPts val="800"/>
-              </a:spcAft>
-            </a:pPr>
+              <a:t>OECD survey</a:t>
+            </a:r>
             <a:r>
               <a:rPr sz="1800">
                 <a:solidFill>
                   <a:srgbClr val="111827"/>
                 </a:solidFill>
               </a:rPr>
-              <a:t>The rules. You change them.</a:t>
-            </a:r>
-          </a:p>
-        </p:txBody>
-      </p:sp>
-      <p:sp>
-        <p:nvSpPr>
-          <p:cNvPr id="9" name="TextBox 8"/>
+              <a:t>, 2026, 36 pages.</a:t>
+            </a:r>
+          </a:p>
+        </p:txBody>
+      </p:sp>
+      <p:sp>
+        <p:nvSpPr>
+          <p:cNvPr id="7" name="TextBox 6"/>
           <p:cNvSpPr txBox="1"/>
           <p:nvPr/>
         </p:nvSpPr>
@@ -6099,7 +5211,7 @@
                   <a:srgbClr val="1A1A1A"/>
                 </a:solidFill>
               </a:rPr>
-              <a:t>LIVE DEMO</a:t>
+              <a:t>YOURS TO TAKE</a:t>
             </a:r>
           </a:p>
         </p:txBody>
@@ -6133,7 +5245,7 @@
                   <a:srgbClr val="6B7280"/>
                 </a:solidFill>
               </a:rPr>
-              <a:t>5 / 11</a:t>
+              <a:t>5 / 6</a:t>
             </a:r>
           </a:p>
         </p:txBody>
@@ -6166,7 +5278,7 @@
                   <a:srgbClr val="111827"/>
                 </a:solidFill>
               </a:rPr>
-              <a:t>Three sources, three formats, one empty wiki</a:t>
+              <a:t>Your team’s copy takes ten minutes</a:t>
             </a:r>
           </a:p>
         </p:txBody>
@@ -6203,41 +5315,9 @@
                 <a:solidFill>
                   <a:srgbClr val="111827"/>
                 </a:solidFill>
-              </a:rPr>
-              <a:t>•  </a:t>
-            </a:r>
-            <a:r>
-              <a:rPr sz="1800" b="1">
-                <a:solidFill>
-                  <a:srgbClr val="111827"/>
-                </a:solidFill>
-              </a:rPr>
-              <a:t>Article.</a:t>
-            </a:r>
-            <a:r>
-              <a:rPr sz="1800">
-                <a:solidFill>
-                  <a:srgbClr val="111827"/>
-                </a:solidFill>
-              </a:rPr>
-              <a:t> </a:t>
-            </a:r>
-            <a:r>
-              <a:rPr sz="1800">
-                <a:solidFill>
-                  <a:srgbClr val="111827"/>
-                </a:solidFill>
                 <a:hlinkClick r:id="rId2"/>
               </a:rPr>
-              <a:t>OECD Cogito blog</a:t>
-            </a:r>
-            <a:r>
-              <a:rPr sz="1800">
-                <a:solidFill>
-                  <a:srgbClr val="111827"/>
-                </a:solidFill>
-              </a:rPr>
-              <a:t>, 2025.</a:t>
+              <a:t>datadrivendecisions/llm-wiki-template</a:t>
             </a:r>
           </a:p>
           <a:p>
@@ -6247,93 +5327,12 @@
               </a:spcAft>
             </a:pPr>
             <a:r>
-              <a:rPr sz="1800">
+              <a:rPr sz="1800" b="1">
                 <a:solidFill>
                   <a:srgbClr val="111827"/>
                 </a:solidFill>
               </a:rPr>
-              <a:t>•  </a:t>
-            </a:r>
-            <a:r>
-              <a:rPr sz="1800" b="1">
-                <a:solidFill>
-                  <a:srgbClr val="111827"/>
-                </a:solidFill>
-              </a:rPr>
-              <a:t>Video.</a:t>
-            </a:r>
-            <a:r>
-              <a:rPr sz="1800">
-                <a:solidFill>
-                  <a:srgbClr val="111827"/>
-                </a:solidFill>
-              </a:rPr>
-              <a:t> </a:t>
-            </a:r>
-            <a:r>
-              <a:rPr sz="1800">
-                <a:solidFill>
-                  <a:srgbClr val="111827"/>
-                </a:solidFill>
-                <a:hlinkClick r:id="rId3"/>
-              </a:rPr>
-              <a:t>Asian Productivity Organization</a:t>
-            </a:r>
-            <a:r>
-              <a:rPr sz="1800">
-                <a:solidFill>
-                  <a:srgbClr val="111827"/>
-                </a:solidFill>
-              </a:rPr>
-              <a:t>, 64 minutes.</a:t>
-            </a:r>
-          </a:p>
-          <a:p>
-            <a:pPr>
-              <a:spcAft>
-                <a:spcPts val="800"/>
-              </a:spcAft>
-            </a:pPr>
-            <a:r>
-              <a:rPr sz="1800">
-                <a:solidFill>
-                  <a:srgbClr val="111827"/>
-                </a:solidFill>
-              </a:rPr>
-              <a:t>•  </a:t>
-            </a:r>
-            <a:r>
-              <a:rPr sz="1800" b="1">
-                <a:solidFill>
-                  <a:srgbClr val="111827"/>
-                </a:solidFill>
-              </a:rPr>
-              <a:t>Report.</a:t>
-            </a:r>
-            <a:r>
-              <a:rPr sz="1800">
-                <a:solidFill>
-                  <a:srgbClr val="111827"/>
-                </a:solidFill>
-              </a:rPr>
-              <a:t> </a:t>
-            </a:r>
-            <a:r>
-              <a:rPr sz="1800">
-                <a:solidFill>
-                  <a:srgbClr val="111827"/>
-                </a:solidFill>
-                <a:hlinkClick r:id="rId4"/>
-              </a:rPr>
-              <a:t>OECD survey</a:t>
-            </a:r>
-            <a:r>
-              <a:rPr sz="1800">
-                <a:solidFill>
-                  <a:srgbClr val="111827"/>
-                </a:solidFill>
-              </a:rPr>
-              <a:t>, 2026, 36 pages.</a:t>
+              <a:t>Never interview material.</a:t>
             </a:r>
           </a:p>
         </p:txBody>
@@ -6460,7 +5459,7 @@
                   <a:srgbClr val="1A1A1A"/>
                 </a:solidFill>
               </a:rPr>
-              <a:t>LIVE DEMO</a:t>
+              <a:t>HOMEWORK</a:t>
             </a:r>
           </a:p>
         </p:txBody>
@@ -6494,7 +5493,7 @@
                   <a:srgbClr val="6B7280"/>
                 </a:solidFill>
               </a:rPr>
-              <a:t>6 / 11</a:t>
+              <a:t>6 / 6</a:t>
             </a:r>
           </a:p>
         </p:txBody>
@@ -6527,7 +5526,7 @@
                   <a:srgbClr val="111827"/>
                 </a:solidFill>
               </a:rPr>
-              <a:t>Watch the pause: it reads, then asks before it writes</a:t>
+              <a:t>Before 12 October: the first evaluation, with your decision log</a:t>
             </a:r>
           </a:p>
         </p:txBody>
@@ -6564,1091 +5563,17 @@
                 <a:solidFill>
                   <a:srgbClr val="111827"/>
                 </a:solidFill>
-              </a:rPr>
-              <a:t>•  </a:t>
-            </a:r>
-            <a:r>
-              <a:rPr sz="1800" b="1">
-                <a:solidFill>
-                  <a:srgbClr val="111827"/>
-                </a:solidFill>
-              </a:rPr>
-              <a:t>The pause.</a:t>
-            </a:r>
-            <a:r>
-              <a:rPr sz="1800">
-                <a:solidFill>
-                  <a:srgbClr val="111827"/>
-                </a:solidFill>
-              </a:rPr>
-              <a:t> Your chance to catch a misreading.</a:t>
-            </a:r>
-          </a:p>
-          <a:p>
-            <a:pPr>
-              <a:spcAft>
-                <a:spcPts val="800"/>
-              </a:spcAft>
-            </a:pPr>
-            <a:r>
-              <a:rPr sz="1800">
-                <a:solidFill>
-                  <a:srgbClr val="111827"/>
-                </a:solidFill>
-              </a:rPr>
-              <a:t>•  </a:t>
-            </a:r>
-            <a:r>
-              <a:rPr sz="1800" b="1">
-                <a:solidFill>
-                  <a:srgbClr val="111827"/>
-                </a:solidFill>
-              </a:rPr>
-              <a:t>The source page.</a:t>
-            </a:r>
-            <a:r>
-              <a:rPr sz="1800">
-                <a:solidFill>
-                  <a:srgbClr val="111827"/>
-                </a:solidFill>
-              </a:rPr>
-              <a:t> Who wrote it; who paid for it.</a:t>
-            </a:r>
-          </a:p>
-          <a:p>
-            <a:pPr>
-              <a:spcAft>
-                <a:spcPts val="800"/>
-              </a:spcAft>
-            </a:pPr>
-            <a:r>
-              <a:rPr sz="1800">
-                <a:solidFill>
-                  <a:srgbClr val="111827"/>
-                </a:solidFill>
-              </a:rPr>
-              <a:t>•  </a:t>
-            </a:r>
-            <a:r>
-              <a:rPr sz="1800" b="1">
-                <a:solidFill>
-                  <a:srgbClr val="111827"/>
-                </a:solidFill>
-              </a:rPr>
-              <a:t>Index and log.</a:t>
-            </a:r>
-            <a:r>
-              <a:rPr sz="1800">
-                <a:solidFill>
-                  <a:srgbClr val="111827"/>
-                </a:solidFill>
-              </a:rPr>
-              <a:t> Every page, every step.</a:t>
-            </a:r>
-          </a:p>
-        </p:txBody>
-      </p:sp>
-      <p:sp>
-        <p:nvSpPr>
-          <p:cNvPr id="7" name="TextBox 6"/>
-          <p:cNvSpPr txBox="1"/>
-          <p:nvPr/>
-        </p:nvSpPr>
-        <p:spPr>
-          <a:xfrm>
-            <a:off x="731520" y="6309360"/>
-            <a:ext cx="7315200" cy="320040"/>
-          </a:xfrm>
-          <a:prstGeom prst="rect">
-            <a:avLst/>
-          </a:prstGeom>
-          <a:noFill/>
-        </p:spPr>
-        <p:txBody>
-          <a:bodyPr wrap="square">
-            <a:spAutoFit/>
-          </a:bodyPr>
-          <a:lstStyle/>
-          <a:p>
-            <a:r>
-              <a:rPr sz="900">
-                <a:solidFill>
-                  <a:srgbClr val="6B7280"/>
-                </a:solidFill>
-              </a:rPr>
-              <a:t>AI in Business · week 5</a:t>
-            </a:r>
-          </a:p>
-        </p:txBody>
-      </p:sp>
-    </p:spTree>
-  </p:cSld>
-  <p:clrMapOvr>
-    <a:masterClrMapping/>
-  </p:clrMapOvr>
-</p:sld>
-</file>
-
-<file path=ppt/slides/slide7.xml><?xml version="1.0" encoding="utf-8"?>
-<p:sld xmlns:a="http://schemas.openxmlformats.org/drawingml/2006/main" xmlns:p="http://schemas.openxmlformats.org/presentationml/2006/main" xmlns:r="http://schemas.openxmlformats.org/officeDocument/2006/relationships">
-  <p:cSld>
-    <p:spTree>
-      <p:nvGrpSpPr>
-        <p:cNvPr id="1" name=""/>
-        <p:cNvGrpSpPr/>
-        <p:nvPr/>
-      </p:nvGrpSpPr>
-      <p:grpSpPr/>
-      <p:sp>
-        <p:nvSpPr>
-          <p:cNvPr id="2" name="Rectangle 1"/>
-          <p:cNvSpPr/>
-          <p:nvPr/>
-        </p:nvSpPr>
-        <p:spPr>
-          <a:xfrm>
-            <a:off x="731520" y="566928"/>
-            <a:ext cx="320040" cy="73152"/>
-          </a:xfrm>
-          <a:prstGeom prst="rect">
-            <a:avLst/>
-          </a:prstGeom>
-          <a:solidFill>
-            <a:srgbClr val="D4DB3E"/>
-          </a:solidFill>
-          <a:ln>
-            <a:noFill/>
-          </a:ln>
-        </p:spPr>
-        <p:style>
-          <a:lnRef idx="1">
-            <a:schemeClr val="accent1"/>
-          </a:lnRef>
-          <a:fillRef idx="3">
-            <a:schemeClr val="accent1"/>
-          </a:fillRef>
-          <a:effectRef idx="2">
-            <a:schemeClr val="accent1"/>
-          </a:effectRef>
-          <a:fontRef idx="minor">
-            <a:schemeClr val="lt1"/>
-          </a:fontRef>
-        </p:style>
-        <p:txBody>
-          <a:bodyPr rtlCol="0" anchor="ctr"/>
-          <a:lstStyle/>
-          <a:p>
-            <a:pPr algn="ctr"/>
-          </a:p>
-        </p:txBody>
-      </p:sp>
-      <p:sp>
-        <p:nvSpPr>
-          <p:cNvPr id="3" name="TextBox 2"/>
-          <p:cNvSpPr txBox="1"/>
-          <p:nvPr/>
-        </p:nvSpPr>
-        <p:spPr>
-          <a:xfrm>
-            <a:off x="1143000" y="411480"/>
-            <a:ext cx="7315200" cy="365760"/>
-          </a:xfrm>
-          <a:prstGeom prst="rect">
-            <a:avLst/>
-          </a:prstGeom>
-          <a:noFill/>
-        </p:spPr>
-        <p:txBody>
-          <a:bodyPr wrap="square">
-            <a:spAutoFit/>
-          </a:bodyPr>
-          <a:lstStyle/>
-          <a:p>
-            <a:r>
-              <a:rPr sz="1100" b="1">
-                <a:solidFill>
-                  <a:srgbClr val="1A1A1A"/>
-                </a:solidFill>
-              </a:rPr>
-              <a:t>LIVE DEMO</a:t>
-            </a:r>
-          </a:p>
-        </p:txBody>
-      </p:sp>
-      <p:sp>
-        <p:nvSpPr>
-          <p:cNvPr id="4" name="TextBox 3"/>
-          <p:cNvSpPr txBox="1"/>
-          <p:nvPr/>
-        </p:nvSpPr>
-        <p:spPr>
-          <a:xfrm>
-            <a:off x="9601200" y="411480"/>
-            <a:ext cx="1828800" cy="365760"/>
-          </a:xfrm>
-          <a:prstGeom prst="rect">
-            <a:avLst/>
-          </a:prstGeom>
-          <a:noFill/>
-        </p:spPr>
-        <p:txBody>
-          <a:bodyPr wrap="square">
-            <a:spAutoFit/>
-          </a:bodyPr>
-          <a:lstStyle/>
-          <a:p>
-            <a:pPr algn="r"/>
-            <a:r>
-              <a:rPr sz="1100">
-                <a:solidFill>
-                  <a:srgbClr val="6B7280"/>
-                </a:solidFill>
-              </a:rPr>
-              <a:t>7 / 11</a:t>
-            </a:r>
-          </a:p>
-        </p:txBody>
-      </p:sp>
-      <p:sp>
-        <p:nvSpPr>
-          <p:cNvPr id="5" name="TextBox 4"/>
-          <p:cNvSpPr txBox="1"/>
-          <p:nvPr/>
-        </p:nvSpPr>
-        <p:spPr>
-          <a:xfrm>
-            <a:off x="731520" y="914400"/>
-            <a:ext cx="10698480" cy="1188720"/>
-          </a:xfrm>
-          <a:prstGeom prst="rect">
-            <a:avLst/>
-          </a:prstGeom>
-          <a:noFill/>
-        </p:spPr>
-        <p:txBody>
-          <a:bodyPr wrap="square">
-            <a:spAutoFit/>
-          </a:bodyPr>
-          <a:lstStyle/>
-          <a:p>
-            <a:r>
-              <a:rPr sz="3200" b="1">
-                <a:solidFill>
-                  <a:srgbClr val="111827"/>
-                </a:solidFill>
-              </a:rPr>
-              <a:t>Two sources, two pictures of AI at small firms</a:t>
-            </a:r>
-          </a:p>
-        </p:txBody>
-      </p:sp>
-      <p:sp>
-        <p:nvSpPr>
-          <p:cNvPr id="6" name="TextBox 5"/>
-          <p:cNvSpPr txBox="1"/>
-          <p:nvPr/>
-        </p:nvSpPr>
-        <p:spPr>
-          <a:xfrm>
-            <a:off x="731520" y="2103120"/>
-            <a:ext cx="5120640" cy="3931920"/>
-          </a:xfrm>
-          <a:prstGeom prst="rect">
-            <a:avLst/>
-          </a:prstGeom>
-          <a:noFill/>
-        </p:spPr>
-        <p:txBody>
-          <a:bodyPr wrap="square">
-            <a:spAutoFit/>
-          </a:bodyPr>
-          <a:lstStyle/>
-          <a:p>
-            <a:pPr>
-              <a:spcAft>
-                <a:spcPts val="800"/>
-              </a:spcAft>
-            </a:pPr>
-            <a:r>
-              <a:rPr sz="1100" b="1">
-                <a:solidFill>
-                  <a:srgbClr val="4B5563"/>
-                </a:solidFill>
-              </a:rPr>
-              <a:t>THE ARTICLE</a:t>
-            </a:r>
-          </a:p>
-          <a:p>
-            <a:pPr>
-              <a:spcAft>
-                <a:spcPts val="800"/>
-              </a:spcAft>
-            </a:pPr>
-            <a:r>
-              <a:rPr sz="1800">
-                <a:solidFill>
-                  <a:srgbClr val="111827"/>
-                </a:solidFill>
-              </a:rPr>
-              <a:t>An AI assistant that “negotiates with suppliers”.</a:t>
-            </a:r>
-          </a:p>
-          <a:p>
-            <a:pPr>
-              <a:spcAft>
-                <a:spcPts val="800"/>
-              </a:spcAft>
-            </a:pPr>
-            <a:r>
-              <a:rPr sz="1800">
-                <a:solidFill>
-                  <a:srgbClr val="111827"/>
-                </a:solidFill>
-              </a:rPr>
-              <a:t>Written by someone from PayPal.</a:t>
-            </a:r>
-          </a:p>
-        </p:txBody>
-      </p:sp>
-      <p:sp>
-        <p:nvSpPr>
-          <p:cNvPr id="7" name="TextBox 6"/>
-          <p:cNvSpPr txBox="1"/>
-          <p:nvPr/>
-        </p:nvSpPr>
-        <p:spPr>
-          <a:xfrm>
-            <a:off x="6309360" y="2103120"/>
-            <a:ext cx="5120640" cy="3931920"/>
-          </a:xfrm>
-          <a:prstGeom prst="rect">
-            <a:avLst/>
-          </a:prstGeom>
-          <a:noFill/>
-        </p:spPr>
-        <p:txBody>
-          <a:bodyPr wrap="square">
-            <a:spAutoFit/>
-          </a:bodyPr>
-          <a:lstStyle/>
-          <a:p>
-            <a:pPr>
-              <a:spcAft>
-                <a:spcPts val="800"/>
-              </a:spcAft>
-            </a:pPr>
-            <a:r>
-              <a:rPr sz="1100" b="1">
-                <a:solidFill>
-                  <a:srgbClr val="4B5563"/>
-                </a:solidFill>
-              </a:rPr>
-              <a:t>THE REPORT</a:t>
-            </a:r>
-          </a:p>
-          <a:p>
-            <a:pPr>
-              <a:spcAft>
-                <a:spcPts val="800"/>
-              </a:spcAft>
-            </a:pPr>
-            <a:r>
-              <a:rPr sz="1800" b="1">
-                <a:solidFill>
-                  <a:srgbClr val="111827"/>
-                </a:solidFill>
-              </a:rPr>
-              <a:t>61 %</a:t>
-            </a:r>
-            <a:r>
-              <a:rPr sz="1800">
-                <a:solidFill>
-                  <a:srgbClr val="111827"/>
-                </a:solidFill>
-              </a:rPr>
-              <a:t> of SMEs use AI. </a:t>
-            </a:r>
-            <a:r>
-              <a:rPr sz="1800" b="1">
-                <a:solidFill>
-                  <a:srgbClr val="111827"/>
-                </a:solidFill>
-              </a:rPr>
-              <a:t>76 %</a:t>
-            </a:r>
-            <a:r>
-              <a:rPr sz="1800">
-                <a:solidFill>
-                  <a:srgbClr val="111827"/>
-                </a:solidFill>
-              </a:rPr>
-              <a:t> of those are “AI novices”.</a:t>
-            </a:r>
-          </a:p>
-          <a:p>
-            <a:pPr>
-              <a:spcAft>
-                <a:spcPts val="800"/>
-              </a:spcAft>
-            </a:pPr>
-            <a:r>
-              <a:rPr sz="1800">
-                <a:solidFill>
-                  <a:srgbClr val="111827"/>
-                </a:solidFill>
-              </a:rPr>
-              <a:t>OECD survey, 2,000+ SMEs.</a:t>
-            </a:r>
-          </a:p>
-        </p:txBody>
-      </p:sp>
-      <p:sp>
-        <p:nvSpPr>
-          <p:cNvPr id="8" name="TextBox 7"/>
-          <p:cNvSpPr txBox="1"/>
-          <p:nvPr/>
-        </p:nvSpPr>
-        <p:spPr>
-          <a:xfrm>
-            <a:off x="731520" y="6309360"/>
-            <a:ext cx="7315200" cy="320040"/>
-          </a:xfrm>
-          <a:prstGeom prst="rect">
-            <a:avLst/>
-          </a:prstGeom>
-          <a:noFill/>
-        </p:spPr>
-        <p:txBody>
-          <a:bodyPr wrap="square">
-            <a:spAutoFit/>
-          </a:bodyPr>
-          <a:lstStyle/>
-          <a:p>
-            <a:r>
-              <a:rPr sz="900">
-                <a:solidFill>
-                  <a:srgbClr val="6B7280"/>
-                </a:solidFill>
-              </a:rPr>
-              <a:t>AI in Business · week 5</a:t>
-            </a:r>
-          </a:p>
-        </p:txBody>
-      </p:sp>
-    </p:spTree>
-  </p:cSld>
-  <p:clrMapOvr>
-    <a:masterClrMapping/>
-  </p:clrMapOvr>
-</p:sld>
-</file>
-
-<file path=ppt/slides/slide8.xml><?xml version="1.0" encoding="utf-8"?>
-<p:sld xmlns:a="http://schemas.openxmlformats.org/drawingml/2006/main" xmlns:p="http://schemas.openxmlformats.org/presentationml/2006/main" xmlns:r="http://schemas.openxmlformats.org/officeDocument/2006/relationships">
-  <p:cSld>
-    <p:spTree>
-      <p:nvGrpSpPr>
-        <p:cNvPr id="1" name=""/>
-        <p:cNvGrpSpPr/>
-        <p:nvPr/>
-      </p:nvGrpSpPr>
-      <p:grpSpPr/>
-      <p:sp>
-        <p:nvSpPr>
-          <p:cNvPr id="2" name="Rectangle 1"/>
-          <p:cNvSpPr/>
-          <p:nvPr/>
-        </p:nvSpPr>
-        <p:spPr>
-          <a:xfrm>
-            <a:off x="731520" y="566928"/>
-            <a:ext cx="320040" cy="73152"/>
-          </a:xfrm>
-          <a:prstGeom prst="rect">
-            <a:avLst/>
-          </a:prstGeom>
-          <a:solidFill>
-            <a:srgbClr val="D4DB3E"/>
-          </a:solidFill>
-          <a:ln>
-            <a:noFill/>
-          </a:ln>
-        </p:spPr>
-        <p:style>
-          <a:lnRef idx="1">
-            <a:schemeClr val="accent1"/>
-          </a:lnRef>
-          <a:fillRef idx="3">
-            <a:schemeClr val="accent1"/>
-          </a:fillRef>
-          <a:effectRef idx="2">
-            <a:schemeClr val="accent1"/>
-          </a:effectRef>
-          <a:fontRef idx="minor">
-            <a:schemeClr val="lt1"/>
-          </a:fontRef>
-        </p:style>
-        <p:txBody>
-          <a:bodyPr rtlCol="0" anchor="ctr"/>
-          <a:lstStyle/>
-          <a:p>
-            <a:pPr algn="ctr"/>
-          </a:p>
-        </p:txBody>
-      </p:sp>
-      <p:sp>
-        <p:nvSpPr>
-          <p:cNvPr id="3" name="TextBox 2"/>
-          <p:cNvSpPr txBox="1"/>
-          <p:nvPr/>
-        </p:nvSpPr>
-        <p:spPr>
-          <a:xfrm>
-            <a:off x="1143000" y="411480"/>
-            <a:ext cx="7315200" cy="365760"/>
-          </a:xfrm>
-          <a:prstGeom prst="rect">
-            <a:avLst/>
-          </a:prstGeom>
-          <a:noFill/>
-        </p:spPr>
-        <p:txBody>
-          <a:bodyPr wrap="square">
-            <a:spAutoFit/>
-          </a:bodyPr>
-          <a:lstStyle/>
-          <a:p>
-            <a:r>
-              <a:rPr sz="1100" b="1">
-                <a:solidFill>
-                  <a:srgbClr val="1A1A1A"/>
-                </a:solidFill>
-              </a:rPr>
-              <a:t>LIVE DEMO</a:t>
-            </a:r>
-          </a:p>
-        </p:txBody>
-      </p:sp>
-      <p:sp>
-        <p:nvSpPr>
-          <p:cNvPr id="4" name="TextBox 3"/>
-          <p:cNvSpPr txBox="1"/>
-          <p:nvPr/>
-        </p:nvSpPr>
-        <p:spPr>
-          <a:xfrm>
-            <a:off x="9601200" y="411480"/>
-            <a:ext cx="1828800" cy="365760"/>
-          </a:xfrm>
-          <a:prstGeom prst="rect">
-            <a:avLst/>
-          </a:prstGeom>
-          <a:noFill/>
-        </p:spPr>
-        <p:txBody>
-          <a:bodyPr wrap="square">
-            <a:spAutoFit/>
-          </a:bodyPr>
-          <a:lstStyle/>
-          <a:p>
-            <a:pPr algn="r"/>
-            <a:r>
-              <a:rPr sz="1100">
-                <a:solidFill>
-                  <a:srgbClr val="6B7280"/>
-                </a:solidFill>
-              </a:rPr>
-              <a:t>8 / 11</a:t>
-            </a:r>
-          </a:p>
-        </p:txBody>
-      </p:sp>
-      <p:sp>
-        <p:nvSpPr>
-          <p:cNvPr id="5" name="TextBox 4"/>
-          <p:cNvSpPr txBox="1"/>
-          <p:nvPr/>
-        </p:nvSpPr>
-        <p:spPr>
-          <a:xfrm>
-            <a:off x="731520" y="914400"/>
-            <a:ext cx="10698480" cy="1188720"/>
-          </a:xfrm>
-          <a:prstGeom prst="rect">
-            <a:avLst/>
-          </a:prstGeom>
-          <a:noFill/>
-        </p:spPr>
-        <p:txBody>
-          <a:bodyPr wrap="square">
-            <a:spAutoFit/>
-          </a:bodyPr>
-          <a:lstStyle/>
-          <a:p>
-            <a:r>
-              <a:rPr sz="3200" b="1">
-                <a:solidFill>
-                  <a:srgbClr val="111827"/>
-                </a:solidFill>
-              </a:rPr>
-              <a:t>Every answer shows its sources, and the log shows what it read</a:t>
-            </a:r>
-          </a:p>
-        </p:txBody>
-      </p:sp>
-      <p:sp>
-        <p:nvSpPr>
-          <p:cNvPr id="6" name="TextBox 5"/>
-          <p:cNvSpPr txBox="1"/>
-          <p:nvPr/>
-        </p:nvSpPr>
-        <p:spPr>
-          <a:xfrm>
-            <a:off x="731520" y="2103120"/>
-            <a:ext cx="10698480" cy="3931920"/>
-          </a:xfrm>
-          <a:prstGeom prst="rect">
-            <a:avLst/>
-          </a:prstGeom>
-          <a:noFill/>
-        </p:spPr>
-        <p:txBody>
-          <a:bodyPr wrap="square">
-            <a:spAutoFit/>
-          </a:bodyPr>
-          <a:lstStyle/>
-          <a:p>
-            <a:pPr>
-              <a:spcAft>
-                <a:spcPts val="800"/>
-              </a:spcAft>
-            </a:pPr>
-            <a:r>
-              <a:rPr sz="1800">
-                <a:solidFill>
-                  <a:srgbClr val="111827"/>
-                </a:solidFill>
-              </a:rPr>
-              <a:t>•  </a:t>
-            </a:r>
-            <a:r>
-              <a:rPr sz="1800" b="1">
-                <a:solidFill>
-                  <a:srgbClr val="111827"/>
-                </a:solidFill>
-              </a:rPr>
-              <a:t>Query.</a:t>
-            </a:r>
-            <a:r>
-              <a:rPr sz="1800">
-                <a:solidFill>
-                  <a:srgbClr val="111827"/>
-                </a:solidFill>
-              </a:rPr>
-              <a:t> A link after every claim.</a:t>
-            </a:r>
-          </a:p>
-          <a:p>
-            <a:pPr>
-              <a:spcAft>
-                <a:spcPts val="800"/>
-              </a:spcAft>
-            </a:pPr>
-            <a:r>
-              <a:rPr sz="1800">
-                <a:solidFill>
-                  <a:srgbClr val="111827"/>
-                </a:solidFill>
-              </a:rPr>
-              <a:t>•  </a:t>
-            </a:r>
-            <a:r>
-              <a:rPr sz="1800" b="1">
-                <a:solidFill>
-                  <a:srgbClr val="111827"/>
-                </a:solidFill>
-              </a:rPr>
-              <a:t>Log.</a:t>
-            </a:r>
-            <a:r>
-              <a:rPr sz="1800">
-                <a:solidFill>
-                  <a:srgbClr val="111827"/>
-                </a:solidFill>
-              </a:rPr>
-              <a:t> The pages each answer read.</a:t>
-            </a:r>
-          </a:p>
-          <a:p>
-            <a:pPr>
-              <a:spcAft>
-                <a:spcPts val="800"/>
-              </a:spcAft>
-            </a:pPr>
-            <a:r>
-              <a:rPr sz="1800">
-                <a:solidFill>
-                  <a:srgbClr val="111827"/>
-                </a:solidFill>
-              </a:rPr>
-              <a:t>•  </a:t>
-            </a:r>
-            <a:r>
-              <a:rPr sz="1800" b="1">
-                <a:solidFill>
-                  <a:srgbClr val="111827"/>
-                </a:solidFill>
-              </a:rPr>
-              <a:t>Lint.</a:t>
-            </a:r>
-            <a:r>
-              <a:rPr sz="1800">
-                <a:solidFill>
-                  <a:srgbClr val="111827"/>
-                </a:solidFill>
-              </a:rPr>
-              <a:t> Every quotation checked against its source.</a:t>
-            </a:r>
-          </a:p>
-        </p:txBody>
-      </p:sp>
-      <p:sp>
-        <p:nvSpPr>
-          <p:cNvPr id="7" name="TextBox 6"/>
-          <p:cNvSpPr txBox="1"/>
-          <p:nvPr/>
-        </p:nvSpPr>
-        <p:spPr>
-          <a:xfrm>
-            <a:off x="731520" y="6309360"/>
-            <a:ext cx="7315200" cy="320040"/>
-          </a:xfrm>
-          <a:prstGeom prst="rect">
-            <a:avLst/>
-          </a:prstGeom>
-          <a:noFill/>
-        </p:spPr>
-        <p:txBody>
-          <a:bodyPr wrap="square">
-            <a:spAutoFit/>
-          </a:bodyPr>
-          <a:lstStyle/>
-          <a:p>
-            <a:r>
-              <a:rPr sz="900">
-                <a:solidFill>
-                  <a:srgbClr val="6B7280"/>
-                </a:solidFill>
-              </a:rPr>
-              <a:t>AI in Business · week 5</a:t>
-            </a:r>
-          </a:p>
-        </p:txBody>
-      </p:sp>
-    </p:spTree>
-  </p:cSld>
-  <p:clrMapOvr>
-    <a:masterClrMapping/>
-  </p:clrMapOvr>
-</p:sld>
-</file>
-
-<file path=ppt/slides/slide9.xml><?xml version="1.0" encoding="utf-8"?>
-<p:sld xmlns:a="http://schemas.openxmlformats.org/drawingml/2006/main" xmlns:p="http://schemas.openxmlformats.org/presentationml/2006/main" xmlns:r="http://schemas.openxmlformats.org/officeDocument/2006/relationships">
-  <p:cSld>
-    <p:spTree>
-      <p:nvGrpSpPr>
-        <p:cNvPr id="1" name=""/>
-        <p:cNvGrpSpPr/>
-        <p:nvPr/>
-      </p:nvGrpSpPr>
-      <p:grpSpPr/>
-      <p:sp>
-        <p:nvSpPr>
-          <p:cNvPr id="2" name="Rectangle 1"/>
-          <p:cNvSpPr/>
-          <p:nvPr/>
-        </p:nvSpPr>
-        <p:spPr>
-          <a:xfrm>
-            <a:off x="731520" y="566928"/>
-            <a:ext cx="320040" cy="73152"/>
-          </a:xfrm>
-          <a:prstGeom prst="rect">
-            <a:avLst/>
-          </a:prstGeom>
-          <a:solidFill>
-            <a:srgbClr val="D4DB3E"/>
-          </a:solidFill>
-          <a:ln>
-            <a:noFill/>
-          </a:ln>
-        </p:spPr>
-        <p:style>
-          <a:lnRef idx="1">
-            <a:schemeClr val="accent1"/>
-          </a:lnRef>
-          <a:fillRef idx="3">
-            <a:schemeClr val="accent1"/>
-          </a:fillRef>
-          <a:effectRef idx="2">
-            <a:schemeClr val="accent1"/>
-          </a:effectRef>
-          <a:fontRef idx="minor">
-            <a:schemeClr val="lt1"/>
-          </a:fontRef>
-        </p:style>
-        <p:txBody>
-          <a:bodyPr rtlCol="0" anchor="ctr"/>
-          <a:lstStyle/>
-          <a:p>
-            <a:pPr algn="ctr"/>
-          </a:p>
-        </p:txBody>
-      </p:sp>
-      <p:sp>
-        <p:nvSpPr>
-          <p:cNvPr id="3" name="TextBox 2"/>
-          <p:cNvSpPr txBox="1"/>
-          <p:nvPr/>
-        </p:nvSpPr>
-        <p:spPr>
-          <a:xfrm>
-            <a:off x="1143000" y="411480"/>
-            <a:ext cx="7315200" cy="365760"/>
-          </a:xfrm>
-          <a:prstGeom prst="rect">
-            <a:avLst/>
-          </a:prstGeom>
-          <a:noFill/>
-        </p:spPr>
-        <p:txBody>
-          <a:bodyPr wrap="square">
-            <a:spAutoFit/>
-          </a:bodyPr>
-          <a:lstStyle/>
-          <a:p>
-            <a:r>
-              <a:rPr sz="1100" b="1">
-                <a:solidFill>
-                  <a:srgbClr val="1A1A1A"/>
-                </a:solidFill>
-              </a:rPr>
-              <a:t>YOURS TO TAKE</a:t>
-            </a:r>
-          </a:p>
-        </p:txBody>
-      </p:sp>
-      <p:sp>
-        <p:nvSpPr>
-          <p:cNvPr id="4" name="TextBox 3"/>
-          <p:cNvSpPr txBox="1"/>
-          <p:nvPr/>
-        </p:nvSpPr>
-        <p:spPr>
-          <a:xfrm>
-            <a:off x="9601200" y="411480"/>
-            <a:ext cx="1828800" cy="365760"/>
-          </a:xfrm>
-          <a:prstGeom prst="rect">
-            <a:avLst/>
-          </a:prstGeom>
-          <a:noFill/>
-        </p:spPr>
-        <p:txBody>
-          <a:bodyPr wrap="square">
-            <a:spAutoFit/>
-          </a:bodyPr>
-          <a:lstStyle/>
-          <a:p>
-            <a:pPr algn="r"/>
-            <a:r>
-              <a:rPr sz="1100">
-                <a:solidFill>
-                  <a:srgbClr val="6B7280"/>
-                </a:solidFill>
-              </a:rPr>
-              <a:t>9 / 11</a:t>
-            </a:r>
-          </a:p>
-        </p:txBody>
-      </p:sp>
-      <p:sp>
-        <p:nvSpPr>
-          <p:cNvPr id="5" name="TextBox 4"/>
-          <p:cNvSpPr txBox="1"/>
-          <p:nvPr/>
-        </p:nvSpPr>
-        <p:spPr>
-          <a:xfrm>
-            <a:off x="731520" y="914400"/>
-            <a:ext cx="10698480" cy="1188720"/>
-          </a:xfrm>
-          <a:prstGeom prst="rect">
-            <a:avLst/>
-          </a:prstGeom>
-          <a:noFill/>
-        </p:spPr>
-        <p:txBody>
-          <a:bodyPr wrap="square">
-            <a:spAutoFit/>
-          </a:bodyPr>
-          <a:lstStyle/>
-          <a:p>
-            <a:r>
-              <a:rPr sz="3200" b="1">
-                <a:solidFill>
-                  <a:srgbClr val="111827"/>
-                </a:solidFill>
-              </a:rPr>
-              <a:t>Your team’s copy takes ten minutes</a:t>
-            </a:r>
-          </a:p>
-        </p:txBody>
-      </p:sp>
-      <p:sp>
-        <p:nvSpPr>
-          <p:cNvPr id="6" name="TextBox 5"/>
-          <p:cNvSpPr txBox="1"/>
-          <p:nvPr/>
-        </p:nvSpPr>
-        <p:spPr>
-          <a:xfrm>
-            <a:off x="731520" y="2103120"/>
-            <a:ext cx="10698480" cy="3931920"/>
-          </a:xfrm>
-          <a:prstGeom prst="rect">
-            <a:avLst/>
-          </a:prstGeom>
-          <a:noFill/>
-        </p:spPr>
-        <p:txBody>
-          <a:bodyPr wrap="square">
-            <a:spAutoFit/>
-          </a:bodyPr>
-          <a:lstStyle/>
-          <a:p>
-            <a:pPr>
-              <a:spcAft>
-                <a:spcPts val="800"/>
-              </a:spcAft>
-            </a:pPr>
-            <a:r>
-              <a:rPr sz="1800">
-                <a:solidFill>
-                  <a:srgbClr val="111827"/>
-                </a:solidFill>
                 <a:hlinkClick r:id="rId2"/>
               </a:rPr>
-              <a:t>datadrivendecisions/llm-wiki-template</a:t>
-            </a:r>
-          </a:p>
-          <a:p>
-            <a:pPr>
-              <a:spcAft>
-                <a:spcPts val="800"/>
-              </a:spcAft>
-            </a:pPr>
+              <a:t>The assignment is here</a:t>
+            </a:r>
             <a:r>
               <a:rPr sz="1800">
                 <a:solidFill>
                   <a:srgbClr val="111827"/>
                 </a:solidFill>
               </a:rPr>
-              <a:t>•  </a:t>
-            </a:r>
-            <a:r>
-              <a:rPr sz="1800" b="1">
-                <a:solidFill>
-                  <a:srgbClr val="111827"/>
-                </a:solidFill>
-              </a:rPr>
-              <a:t>Use this template</a:t>
-            </a:r>
-            <a:r>
-              <a:rPr sz="1800">
-                <a:solidFill>
-                  <a:srgbClr val="111827"/>
-                </a:solidFill>
-              </a:rPr>
-              <a:t> → a new repository.</a:t>
-            </a:r>
-          </a:p>
-          <a:p>
-            <a:pPr>
-              <a:spcAft>
-                <a:spcPts val="800"/>
-              </a:spcAft>
-            </a:pPr>
-            <a:r>
-              <a:rPr sz="1800">
-                <a:solidFill>
-                  <a:srgbClr val="111827"/>
-                </a:solidFill>
-              </a:rPr>
-              <a:t>•  </a:t>
-            </a:r>
-            <a:r>
-              <a:rPr sz="1800" b="1">
-                <a:solidFill>
-                  <a:srgbClr val="111827"/>
-                </a:solidFill>
-              </a:rPr>
-              <a:t>Clone, install,</a:t>
-            </a:r>
-            <a:r>
-              <a:rPr sz="1800">
-                <a:solidFill>
-                  <a:srgbClr val="111827"/>
-                </a:solidFill>
-              </a:rPr>
-              <a:t> run the check.</a:t>
-            </a:r>
-          </a:p>
-          <a:p>
-            <a:pPr>
-              <a:spcAft>
-                <a:spcPts val="800"/>
-              </a:spcAft>
-            </a:pPr>
-            <a:r>
-              <a:rPr sz="1800">
-                <a:solidFill>
-                  <a:srgbClr val="111827"/>
-                </a:solidFill>
-              </a:rPr>
-              <a:t>•  </a:t>
-            </a:r>
-            <a:r>
-              <a:rPr sz="1800" b="1">
-                <a:solidFill>
-                  <a:srgbClr val="111827"/>
-                </a:solidFill>
-              </a:rPr>
-              <a:t>Ingest</a:t>
-            </a:r>
-            <a:r>
-              <a:rPr sz="1800">
-                <a:solidFill>
-                  <a:srgbClr val="111827"/>
-                </a:solidFill>
-              </a:rPr>
-              <a:t> one published source.</a:t>
-            </a:r>
-          </a:p>
-          <a:p>
-            <a:pPr>
-              <a:spcAft>
-                <a:spcPts val="800"/>
-              </a:spcAft>
-            </a:pPr>
-            <a:r>
-              <a:rPr sz="1800" b="1">
-                <a:solidFill>
-                  <a:srgbClr val="111827"/>
-                </a:solidFill>
-              </a:rPr>
-              <a:t>Never interview material.</a:t>
+              <a:t>.</a:t>
             </a:r>
           </a:p>
         </p:txBody>

</xml_diff>

<commit_message>
Week 5 run sheet: ingest the video and report before class, the article live
The dry run of all three ingests finished: the article took under five minutes, the video ten
and a half, the report seventeen. Only the article fits in a session, so the notes now have the
other two ingested the day before. That also improves the demo: the article then lands on a
wiki that already holds the OECD survey, and the disagreement between them appears live rather
than being narrated. The notes describe what the dry run actually recorded (3.6% of AI users on
agentic AI against the article's present-tense agents, confidence down to 0.65) instead of what
it was expected to find, and name the dry-run wiki as the fallback.

The worklog gets two check rows: the template's end-to-end dry run, and the prose, slide and
link checks on the week-5 pages.

Co-Authored-By: Claude Opus 5.5 <noreply@anthropic.com>
</commit_message>
<xml_diff>
--- a/project-documentation/slides/week-05-deck.pptx
+++ b/project-documentation/slides/week-05-deck.pptx
@@ -729,12 +729,18 @@
           <a:p/>
           <a:p>
             <a:r>
-              <a:t>Acquire, one command per format:</a:t>
+              <a:t>Before class (the day before). Create the demo repository from the template, install the helpers, and acquire and ingest the video and the report. They are too long to run live: in the dry run on 30 September (headless, no pause) the video took 10½ minutes and the report 17. Commit after each. The article stays in `raw/` un-ingested, or is fetched live.</a:t>
             </a:r>
           </a:p>
           <a:p/>
           <a:p>
             <a:r>
+              <a:t>Acquire, one command per format (show at least the article live; the other two take seconds):</a:t>
+            </a:r>
+          </a:p>
+          <a:p/>
+          <a:p>
+            <a:r>
               <a:t>• Article: `python3 tools/fetch_article.py https://oecdcogito.blog/2025/09/16/agentic-ai-for-small-business-growth/` — about 1,800 words, word for word.</a:t>
             </a:r>
           </a:p>
@@ -751,7 +757,7 @@
           <a:p/>
           <a:p>
             <a:r>
-              <a:t>Process: `/ingest raw/articles/agentic-ai-for-small-business-growth.md — added by Witek`. Let the pause happen; read the takeaways aloud before saying go. Dry run on 30 September, headless, no pause: the article took just under five minutes and wrote twelve pages. With the pause and talking, budget eight. If time is short, ingest the video and the report while talking.</a:t>
+              <a:t>Live: the article. `/ingest raw/articles/agentic-ai-for-small-business-growth.md — added by Witek`. Let the pause happen and read the takeaways aloud before saying go. On an empty wiki it took just under five minutes; on top of the report and the video expect longer, so budget ten with the pause and talk. Because the survey is already in, the disagreement appears live.</a:t>
             </a:r>
           </a:p>
           <a:p/>
@@ -773,12 +779,18 @@
           </a:p>
           <a:p>
             <a:r>
-              <a:t>3. The disagreement, once the report is in: the article's assistant "negotiates with suppliers"; the OECD finds 61% of SMEs use AI and 76% of those are "AI novices". Show the Debates section and the confidence number that went down. The OECD calls its own sample non-representative, and the source page should say so.</a:t>
+              <a:t>3. The disagreement. In the dry run it landed on the `agentic-ai` concept page under Debates: the article writes in the present tense about agents that reorder stock and negotiate with suppliers; the OECD survey counts 3.6% of AI users running agentic AI, in a sample it says is not representative and skews to the digitally mature. The page says what the disagreement turns on (partly tense, partly being found by other people's agents versus running your own) and the page's confidence dropped to 0.65.</a:t>
             </a:r>
           </a:p>
           <a:p>
             <a:r>
               <a:t>4. Query and lint. Ask: *Which AI uses pay off first for a small manufacturer, according to the wiki?* Show the citations, then the query entry in the log with the pages it read. Then `/lint`, and dwell on the quote check: every quotation on a wiki page is compared with the raw file, so an invented quotation fails. These are the two habits the knowledge architecture criteria said would come back in week 5.</a:t>
+            </a:r>
+          </a:p>
+          <a:p/>
+          <a:p>
+            <a:r>
+              <a:t>Fallback. The dry-run wiki, all three sources ingested and lint clean (52 pages), is on the lecturer's laptop outside the repositories. Open it in Obsidian if the network or the model fails.</a:t>
             </a:r>
           </a:p>
         </p:txBody>

</xml_diff>

<commit_message>
Week 5 slide 3 becomes the LLM wiki pipeline diagram, filling the slide
The owner tells how the system works from one picture: raw sources, the two-stage ingest with
its failure modes, the wiki, the query loop, and the comparison with query-time RAG. The card
that listed three folders is replaced by SmartScope's context-pipeline diagram, credited and
linked on the slide, with the story moved into the notes and a paragraph on where the diagram
and the template differ (syntheses/ for queries/, AGENTS.md for schema.md, and meeting notes
that are never our interview notes).

No card had carried an image before, so build_deck.py gains an is-figure card: the deck and
the PPTX show the image alone at full slide height, with the credit in a strip beneath it,
and the headline stays in the markup for the slide list. The slide-deck skill documents it.
The image is a 256-colour copy of the original, 500 KB instead of 1.5 MB, in site/img/.

Co-Authored-By: Claude Opus 5.5 <noreply@anthropic.com>
</commit_message>
<xml_diff>
--- a/project-documentation/slides/week-05-deck.pptx
+++ b/project-documentation/slides/week-05-deck.pptx
@@ -647,13 +647,50 @@
           <a:lstStyle/>
           <a:p>
             <a:r>
-              <a:t>Most of what the teams built in week 4 looks things up when a question is asked: files uploaded to a chat, a folder the assistant searches, a vector store. That works, and it forgets. Ask twice and it does the work twice; a contradiction between two sources is found only if a question happens to touch both. Karpathy: the LLM "is rediscovering knowledge from scratch on every question". The week 3 visualisation (one question, four ways) is the reminder that this is one of four options.</a:t>
+              <a:t>The diagram fills the slide; tell it left to right, then bottom.</a:t>
             </a:r>
           </a:p>
           <a:p/>
           <a:p>
             <a:r>
-              <a:t>Then the three folders, three owners. raw/ is the evidence and nobody edits it, the assistant included. wiki/ belongs to the assistant; the team reads and asks for changes. AGENTS.md is the contract, and the team changes it. All six assistants the students use read AGENTS.md; CLAUDE.md and GEMINI.md point to it.</a:t>
+              <a:t>• Start at the bottom row, the comparison. Query-time RAG: question, search raw, synthesise on the spot, and only the answer remains. That is what most teams built in week 4: it works, and it forgets. Karpathy: the LLM "is rediscovering knowledge from scratch on every question". The wiki row ends differently: artifacts remain, and are reused and improved.</a:t>
+            </a:r>
+          </a:p>
+          <a:p>
+            <a:r>
+              <a:t>• Raw sources, top left. The source of truth. The model reads them and never modifies them.</a:t>
+            </a:r>
+          </a:p>
+          <a:p>
+            <a:r>
+              <a:t>• Ingest, the orange box. Two stages: analysis (entities, concepts, links to what is already in the wiki, contradictions and open questions), then generation (the source summary, entity and concept pages, index and log). This is the step the demo shows.</a:t>
+            </a:r>
+          </a:p>
+          <a:p>
+            <a:r>
+              <a:t>• The red boxes are the honest part. The same source ingested twice will not give identical pages. A summary drops details. A wrong summary stays as markdown and gets built on: error cementing. This is why the template pauses before writing, checks every quotation against the raw file, and keeps a log.</a:t>
+            </a:r>
+          </a:p>
+          <a:p>
+            <a:r>
+              <a:t>• LLM wiki, top right. Plain markdown files a person can read. The review queue (contradictions, duplicates, missing pages) is what the lint reports.</a:t>
+            </a:r>
+          </a:p>
+          <a:p>
+            <a:r>
+              <a:t>• Query loop, the purple row. A question searches the wiki pages and, where needed, the raw sources, fills the context window, and a good answer is saved back to the wiki. Retrieval does not disappear; it gets a better index.</a:t>
+            </a:r>
+          </a:p>
+          <a:p/>
+          <a:p>
+            <a:r>
+              <a:t>Where the template differs from the diagram: `syntheses/` instead of `queries/`, `AGENTS.md` instead of `schema.md`, no `overview.md`. And "meeting notes" as a raw source is fine for a company, never for our field research: no interview material in the wiki.</a:t>
+            </a:r>
+          </a:p>
+          <a:p/>
+          <a:p>
+            <a:r>
+              <a:t>All six assistants the students use read `AGENTS.md`; `CLAUDE.md` and `GEMINI.md` in the template point to it. Week 3's visualisation (one question, four ways) is the reminder that this is one of four options.</a:t>
             </a:r>
           </a:p>
         </p:txBody>
@@ -4414,49 +4451,30 @@
         <p:nvPr/>
       </p:nvGrpSpPr>
       <p:grpSpPr/>
-      <p:sp>
-        <p:nvSpPr>
-          <p:cNvPr id="2" name="Rectangle 1"/>
-          <p:cNvSpPr/>
+      <p:pic>
+        <p:nvPicPr>
+          <p:cNvPr id="2" name="Picture 1" descr="llm-wiki-context-pipeline-en.png"/>
+          <p:cNvPicPr>
+            <a:picLocks noChangeAspect="1"/>
+          </p:cNvPicPr>
           <p:nvPr/>
-        </p:nvSpPr>
+        </p:nvPicPr>
+        <p:blipFill>
+          <a:blip r:embed="rId2"/>
+          <a:stretch>
+            <a:fillRect/>
+          </a:stretch>
+        </p:blipFill>
         <p:spPr>
           <a:xfrm>
-            <a:off x="731520" y="566928"/>
-            <a:ext cx="320040" cy="73152"/>
+            <a:off x="1192377" y="0"/>
+            <a:ext cx="9806940" cy="6537960"/>
           </a:xfrm>
           <a:prstGeom prst="rect">
             <a:avLst/>
           </a:prstGeom>
-          <a:solidFill>
-            <a:srgbClr val="D4DB3E"/>
-          </a:solidFill>
-          <a:ln>
-            <a:noFill/>
-          </a:ln>
         </p:spPr>
-        <p:style>
-          <a:lnRef idx="1">
-            <a:schemeClr val="accent1"/>
-          </a:lnRef>
-          <a:fillRef idx="3">
-            <a:schemeClr val="accent1"/>
-          </a:fillRef>
-          <a:effectRef idx="2">
-            <a:schemeClr val="accent1"/>
-          </a:effectRef>
-          <a:fontRef idx="minor">
-            <a:schemeClr val="lt1"/>
-          </a:fontRef>
-        </p:style>
-        <p:txBody>
-          <a:bodyPr rtlCol="0" anchor="ctr"/>
-          <a:lstStyle/>
-          <a:p>
-            <a:pPr algn="ctr"/>
-          </a:p>
-        </p:txBody>
-      </p:sp>
+      </p:pic>
       <p:sp>
         <p:nvSpPr>
           <p:cNvPr id="3" name="TextBox 2"/>
@@ -4465,8 +4483,8 @@
         </p:nvSpPr>
         <p:spPr>
           <a:xfrm>
-            <a:off x="1143000" y="411480"/>
-            <a:ext cx="7315200" cy="365760"/>
+            <a:off x="7436815" y="6528816"/>
+            <a:ext cx="4572000" cy="274320"/>
           </a:xfrm>
           <a:prstGeom prst="rect">
             <a:avLst/>
@@ -4479,296 +4497,14 @@
           </a:bodyPr>
           <a:lstStyle/>
           <a:p>
-            <a:r>
-              <a:rPr sz="1100" b="1">
-                <a:solidFill>
-                  <a:srgbClr val="1A1A1A"/>
+            <a:pPr algn="r"/>
+            <a:r>
+              <a:rPr sz="800">
+                <a:solidFill>
+                  <a:srgbClr val="6B7280"/>
                 </a:solidFill>
               </a:rPr>
-              <a:t>KNOWLEDGE ARCHITECTURE</a:t>
-            </a:r>
-          </a:p>
-        </p:txBody>
-      </p:sp>
-      <p:sp>
-        <p:nvSpPr>
-          <p:cNvPr id="4" name="TextBox 3"/>
-          <p:cNvSpPr txBox="1"/>
-          <p:nvPr/>
-        </p:nvSpPr>
-        <p:spPr>
-          <a:xfrm>
-            <a:off x="9601200" y="411480"/>
-            <a:ext cx="1828800" cy="365760"/>
-          </a:xfrm>
-          <a:prstGeom prst="rect">
-            <a:avLst/>
-          </a:prstGeom>
-          <a:noFill/>
-        </p:spPr>
-        <p:txBody>
-          <a:bodyPr wrap="square">
-            <a:spAutoFit/>
-          </a:bodyPr>
-          <a:lstStyle/>
-          <a:p>
-            <a:pPr algn="r"/>
-            <a:r>
-              <a:rPr sz="1100">
-                <a:solidFill>
-                  <a:srgbClr val="6B7280"/>
-                </a:solidFill>
-              </a:rPr>
-              <a:t>3 / 6</a:t>
-            </a:r>
-          </a:p>
-        </p:txBody>
-      </p:sp>
-      <p:sp>
-        <p:nvSpPr>
-          <p:cNvPr id="5" name="TextBox 4"/>
-          <p:cNvSpPr txBox="1"/>
-          <p:nvPr/>
-        </p:nvSpPr>
-        <p:spPr>
-          <a:xfrm>
-            <a:off x="731520" y="914400"/>
-            <a:ext cx="10698480" cy="1188720"/>
-          </a:xfrm>
-          <a:prstGeom prst="rect">
-            <a:avLst/>
-          </a:prstGeom>
-          <a:noFill/>
-        </p:spPr>
-        <p:txBody>
-          <a:bodyPr wrap="square">
-            <a:spAutoFit/>
-          </a:bodyPr>
-          <a:lstStyle/>
-          <a:p>
-            <a:r>
-              <a:rPr sz="3200" b="1">
-                <a:solidFill>
-                  <a:srgbClr val="111827"/>
-                </a:solidFill>
-              </a:rPr>
-              <a:t>An LLM wiki reads each source once and keeps what it read</a:t>
-            </a:r>
-          </a:p>
-        </p:txBody>
-      </p:sp>
-      <p:sp>
-        <p:nvSpPr>
-          <p:cNvPr id="6" name="TextBox 5"/>
-          <p:cNvSpPr txBox="1"/>
-          <p:nvPr/>
-        </p:nvSpPr>
-        <p:spPr>
-          <a:xfrm>
-            <a:off x="731520" y="2103120"/>
-            <a:ext cx="3261360" cy="3931920"/>
-          </a:xfrm>
-          <a:prstGeom prst="rect">
-            <a:avLst/>
-          </a:prstGeom>
-          <a:noFill/>
-        </p:spPr>
-        <p:txBody>
-          <a:bodyPr wrap="square">
-            <a:spAutoFit/>
-          </a:bodyPr>
-          <a:lstStyle/>
-          <a:p>
-            <a:pPr>
-              <a:spcAft>
-                <a:spcPts val="800"/>
-              </a:spcAft>
-            </a:pPr>
-            <a:r>
-              <a:rPr sz="1100" b="1">
-                <a:solidFill>
-                  <a:srgbClr val="4B5563"/>
-                </a:solidFill>
-              </a:rPr>
-              <a:t>RAW/</a:t>
-            </a:r>
-          </a:p>
-          <a:p>
-            <a:pPr>
-              <a:spcAft>
-                <a:spcPts val="800"/>
-              </a:spcAft>
-            </a:pPr>
-            <a:r>
-              <a:rPr sz="1800">
-                <a:solidFill>
-                  <a:srgbClr val="111827"/>
-                </a:solidFill>
-              </a:rPr>
-              <a:t>The sources. Never edited.</a:t>
-            </a:r>
-          </a:p>
-        </p:txBody>
-      </p:sp>
-      <p:sp>
-        <p:nvSpPr>
-          <p:cNvPr id="7" name="TextBox 6"/>
-          <p:cNvSpPr txBox="1"/>
-          <p:nvPr/>
-        </p:nvSpPr>
-        <p:spPr>
-          <a:xfrm>
-            <a:off x="4450080" y="2103120"/>
-            <a:ext cx="3261360" cy="3931920"/>
-          </a:xfrm>
-          <a:prstGeom prst="rect">
-            <a:avLst/>
-          </a:prstGeom>
-          <a:noFill/>
-        </p:spPr>
-        <p:txBody>
-          <a:bodyPr wrap="square">
-            <a:spAutoFit/>
-          </a:bodyPr>
-          <a:lstStyle/>
-          <a:p>
-            <a:pPr>
-              <a:spcAft>
-                <a:spcPts val="800"/>
-              </a:spcAft>
-            </a:pPr>
-            <a:r>
-              <a:rPr sz="1100" b="1">
-                <a:solidFill>
-                  <a:srgbClr val="4B5563"/>
-                </a:solidFill>
-              </a:rPr>
-              <a:t>WIKI/</a:t>
-            </a:r>
-          </a:p>
-          <a:p>
-            <a:pPr>
-              <a:spcAft>
-                <a:spcPts val="800"/>
-              </a:spcAft>
-            </a:pPr>
-            <a:r>
-              <a:rPr sz="1800">
-                <a:solidFill>
-                  <a:srgbClr val="111827"/>
-                </a:solidFill>
-              </a:rPr>
-              <a:t>The pages. The assistant writes.</a:t>
-            </a:r>
-          </a:p>
-        </p:txBody>
-      </p:sp>
-      <p:sp>
-        <p:nvSpPr>
-          <p:cNvPr id="8" name="TextBox 7"/>
-          <p:cNvSpPr txBox="1"/>
-          <p:nvPr/>
-        </p:nvSpPr>
-        <p:spPr>
-          <a:xfrm>
-            <a:off x="8168640" y="2103120"/>
-            <a:ext cx="3261360" cy="3931920"/>
-          </a:xfrm>
-          <a:prstGeom prst="rect">
-            <a:avLst/>
-          </a:prstGeom>
-          <a:noFill/>
-        </p:spPr>
-        <p:txBody>
-          <a:bodyPr wrap="square">
-            <a:spAutoFit/>
-          </a:bodyPr>
-          <a:lstStyle/>
-          <a:p>
-            <a:pPr>
-              <a:spcAft>
-                <a:spcPts val="800"/>
-              </a:spcAft>
-            </a:pPr>
-            <a:r>
-              <a:rPr sz="1100" b="1">
-                <a:solidFill>
-                  <a:srgbClr val="4B5563"/>
-                </a:solidFill>
-              </a:rPr>
-              <a:t>AGENTS.MD</a:t>
-            </a:r>
-          </a:p>
-          <a:p>
-            <a:pPr>
-              <a:spcAft>
-                <a:spcPts val="800"/>
-              </a:spcAft>
-            </a:pPr>
-            <a:r>
-              <a:rPr sz="1800">
-                <a:solidFill>
-                  <a:srgbClr val="111827"/>
-                </a:solidFill>
-              </a:rPr>
-              <a:t>The rules. You change them.</a:t>
-            </a:r>
-          </a:p>
-          <a:p>
-            <a:pPr>
-              <a:spcAft>
-                <a:spcPts val="800"/>
-              </a:spcAft>
-            </a:pPr>
-            <a:r>
-              <a:rPr sz="1800">
-                <a:solidFill>
-                  <a:srgbClr val="111827"/>
-                </a:solidFill>
-                <a:hlinkClick r:id="rId2"/>
-              </a:rPr>
-              <a:t>Karpathy, LLM Wiki</a:t>
-            </a:r>
-            <a:r>
-              <a:rPr sz="1800">
-                <a:solidFill>
-                  <a:srgbClr val="111827"/>
-                </a:solidFill>
-              </a:rPr>
-              <a:t>, April 2026.</a:t>
-            </a:r>
-          </a:p>
-        </p:txBody>
-      </p:sp>
-      <p:sp>
-        <p:nvSpPr>
-          <p:cNvPr id="9" name="TextBox 8"/>
-          <p:cNvSpPr txBox="1"/>
-          <p:nvPr/>
-        </p:nvSpPr>
-        <p:spPr>
-          <a:xfrm>
-            <a:off x="731520" y="6309360"/>
-            <a:ext cx="7315200" cy="320040"/>
-          </a:xfrm>
-          <a:prstGeom prst="rect">
-            <a:avLst/>
-          </a:prstGeom>
-          <a:noFill/>
-        </p:spPr>
-        <p:txBody>
-          <a:bodyPr wrap="square">
-            <a:spAutoFit/>
-          </a:bodyPr>
-          <a:lstStyle/>
-          <a:p>
-            <a:r>
-              <a:rPr sz="900">
-                <a:solidFill>
-                  <a:srgbClr val="6B7280"/>
-                </a:solidFill>
-              </a:rPr>
-              <a:t>AI in Business · week 5</a:t>
+              <a:t>Diagram: SmartScope, LLM Wiki Architecture, 2026.</a:t>
             </a:r>
           </a:p>
         </p:txBody>

</xml_diff>